<commit_message>
Một slide NỘI DUNG thay cho bảy slide phân đoạn
Bảy slide phân đoạn chiếm 7 trên 37 slide của một bài 15 phút mà không truyền
tải gì. Thay bằng một slide NỘI DUNG đặt ngay sau bìa, theo đúng cấu trúc năm
mục chuẩn của luận văn: tổng quan, cơ sở lý thuyết, phân tích và thiết kế,
kết quả thực nghiệm, kết luận và hướng phát triển. Người nghe biết đang ở đâu
nhờ slide này chứ không cần bảy tấm bảng tên.

37 slide xuống 30.

Ghi rõ quy ước mới vào khối chú thích đầu tệp, kèm lý do đã bỏ, để lần sau
không ai thêm lại.

Nhân tiện sửa một slide mồ côi do chính tôi tạo ra khi thêm slide cơ sở dữ
liệu: đặt câu kết luận xuống DƯỚI bảng, đúng thứ mà quy ước số 2 trong chính
tệp đó cấm. Pandoc cắt sang slide mới, sinh ra một slide lấy nửa câu làm tiêu
đề. Chuyển câu kết luận lên trên bảng và rút gọn cho vừa cột.

Đo lại bằng PowerPoint COM: 30 slide, 0 chỗ tràn chữ hay tràn hình.

Co-Authored-By: Claude Fable 5 <noreply@anthropic.com>
</commit_message>
<xml_diff>
--- a/docs/slides/slides.pptx
+++ b/docs/slides/slides.pptx
@@ -35,30 +35,23 @@
     <p:sldId id="283" r:id="rId32"/>
     <p:sldId id="284" r:id="rId33"/>
     <p:sldId id="285" r:id="rId34"/>
-    <p:sldId id="286" r:id="rId35"/>
-    <p:sldId id="287" r:id="rId36"/>
-    <p:sldId id="288" r:id="rId37"/>
-    <p:sldId id="289" r:id="rId38"/>
-    <p:sldId id="290" r:id="rId39"/>
-    <p:sldId id="291" r:id="rId40"/>
-    <p:sldId id="292" r:id="rId41"/>
   </p:sldIdLst>
   <p:sldSz cx="12192000" cy="6858000"/>
   <p:notesSz cx="6858000" cy="9144000"/>
   <p:embeddedFontLst>
     <p:embeddedFont>
       <p:font typeface="Roboto"/>
-      <p:regular r:id="rId42"/>
-      <p:bold r:id="rId43"/>
-      <p:italic r:id="rId44"/>
-      <p:boldItalic r:id="rId45"/>
+      <p:regular r:id="rId35"/>
+      <p:bold r:id="rId36"/>
+      <p:italic r:id="rId37"/>
+      <p:boldItalic r:id="rId38"/>
     </p:embeddedFont>
     <p:embeddedFont>
       <p:font typeface="Open Sans"/>
-      <p:regular r:id="rId46"/>
-      <p:bold r:id="rId47"/>
-      <p:italic r:id="rId48"/>
-      <p:boldItalic r:id="rId49"/>
+      <p:regular r:id="rId39"/>
+      <p:bold r:id="rId40"/>
+      <p:italic r:id="rId41"/>
+      <p:boldItalic r:id="rId42"/>
     </p:embeddedFont>
   </p:embeddedFontLst>
   <p:defaultTextStyle>
@@ -292,7 +285,7 @@
   </p:defaultTextStyle>
   <p:extLst>
     <p:ext uri="GoogleSlidesCustomDataVersion2">
-      <go:slidesCustomData xmlns:go="http://customooxmlschemas.google.com/" roundtripDataSignature="AMtx7mhu5dURU4INwSlvEO7StWDXKr50jg==" r:id="rId50"/>
+      <go:slidesCustomData xmlns:go="http://customooxmlschemas.google.com/" roundtripDataSignature="AMtx7mhu5dURU4INwSlvEO7StWDXKr50jg==" r:id="rId43"/>
     </p:ext>
   </p:extLst>
 </p:presentation>
@@ -43989,1209 +43982,6 @@
   <p:cSld>
     <p:spTree>
       <p:nvGrpSpPr>
-        <p:cNvPr id="428" name="Shape 428"/>
-        <p:cNvGrpSpPr/>
-        <p:nvPr/>
-      </p:nvGrpSpPr>
-      <p:grpSpPr>
-        <a:xfrm>
-          <a:off x="0" y="0"/>
-          <a:ext cx="0" cy="0"/>
-          <a:chOff x="0" y="0"/>
-          <a:chExt cx="0" cy="0"/>
-        </a:xfrm>
-      </p:grpSpPr>
-      <p:sp>
-        <p:nvSpPr>
-          <p:cNvPr id="436" name="Google Shape;436;p31"/>
-          <p:cNvSpPr txBox="1"/>
-          <p:nvPr>
-            <p:ph type="title"/>
-          </p:nvPr>
-        </p:nvSpPr>
-        <p:spPr>
-          <a:xfrm>
-            <a:off x="774146" y="202009"/>
-            <a:ext cx="3932227" cy="1698043"/>
-          </a:xfrm>
-          <a:prstGeom prst="rect">
-            <a:avLst/>
-          </a:prstGeom>
-          <a:noFill/>
-          <a:ln>
-            <a:noFill/>
-          </a:ln>
-        </p:spPr>
-        <p:txBody>
-          <a:bodyPr/>
-          <a:lstStyle/>
-          <a:p>
-            <a:pPr lvl="0" indent="0" marL="0">
-              <a:buNone/>
-            </a:pPr>
-            <a:r>
-              <a:rPr/>
-              <a:t>Kiến trúc 5 tầng</a:t>
-            </a:r>
-          </a:p>
-        </p:txBody>
-      </p:sp>
-      <p:sp>
-        <p:nvSpPr>
-          <p:cNvPr id="437" name="Google Shape;437;p31"/>
-          <p:cNvSpPr txBox="1"/>
-          <p:nvPr>
-            <p:ph idx="2" sz="half" type="body"/>
-          </p:nvPr>
-        </p:nvSpPr>
-        <p:spPr/>
-        <p:txBody>
-          <a:bodyPr/>
-          <a:lstStyle/>
-          <a:p>
-            <a:pPr lvl="0" indent="0" marL="0">
-              <a:buNone/>
-            </a:pPr>
-            <a:r>
-              <a:rPr/>
-              <a:t>Tầng AI là </a:t>
-            </a:r>
-            <a:r>
-              <a:rPr b="1"/>
-              <a:t>Python thuần</a:t>
-            </a:r>
-            <a:r>
-              <a:rPr/>
-              <a:t> — cấm import FastAPI hoặc Pydantic. Nó không có mũi tên nào đi lên, nên thay engine OCR </a:t>
-            </a:r>
-            <a:r>
-              <a:rPr b="1"/>
-              <a:t>không đụng một dòng mã API</a:t>
-            </a:r>
-          </a:p>
-        </p:txBody>
-      </p:sp>
-      <p:graphicFrame>
-        <p:nvGraphicFramePr>
-          <p:cNvPr id="6" name="Content Placeholder 5"/>
-          <p:cNvGraphicFramePr>
-            <a:graphicFrameLocks noGrp="1"/>
-          </p:cNvGraphicFramePr>
-          <p:nvPr>
-            <p:ph idx="1"/>
-          </p:nvPr>
-        </p:nvGraphicFramePr>
-        <p:xfrm>
-          <a:off x="5156200" y="190500"/>
-          <a:ext cx="6235700" cy="5969000"/>
-        </p:xfrm>
-        <a:graphic>
-          <a:graphicData uri="http://schemas.openxmlformats.org/drawingml/2006/table">
-            <a:tbl>
-              <a:tblPr firstRow="1" bandRow="1">
-                <a:tableStyleId>{45BEF19B-5B1D-4A26-B267-ECC71EF7E2D4}</a:tableStyleId>
-              </a:tblPr>
-              <a:tblGrid>
-                <a:gridCol w="3111500"/>
-                <a:gridCol w="3111500"/>
-              </a:tblGrid>
-              <a:tr h="0">
-                <a:tc>
-                  <a:txBody>
-                    <a:bodyPr/>
-                    <a:lstStyle/>
-                    <a:p>
-                      <a:pPr lvl="0" indent="0" marL="0">
-                        <a:buNone/>
-                      </a:pPr>
-                      <a:r>
-                        <a:rPr/>
-                        <a:t>Tầng</a:t>
-                      </a:r>
-                    </a:p>
-                  </a:txBody>
-                  <a:tcPr/>
-                </a:tc>
-                <a:tc>
-                  <a:txBody>
-                    <a:bodyPr/>
-                    <a:lstStyle/>
-                    <a:p>
-                      <a:pPr lvl="0" indent="0" marL="0">
-                        <a:buNone/>
-                      </a:pPr>
-                      <a:r>
-                        <a:rPr/>
-                        <a:t>Công nghệ</a:t>
-                      </a:r>
-                    </a:p>
-                  </a:txBody>
-                  <a:tcPr/>
-                </a:tc>
-              </a:tr>
-              <a:tr h="0">
-                <a:tc>
-                  <a:txBody>
-                    <a:bodyPr/>
-                    <a:lstStyle/>
-                    <a:p>
-                      <a:pPr lvl="0" indent="0" marL="0">
-                        <a:buNone/>
-                      </a:pPr>
-                      <a:r>
-                        <a:rPr/>
-                        <a:t>L1 — Trình bày</a:t>
-                      </a:r>
-                    </a:p>
-                  </a:txBody>
-                </a:tc>
-                <a:tc>
-                  <a:txBody>
-                    <a:bodyPr/>
-                    <a:lstStyle/>
-                    <a:p>
-                      <a:pPr lvl="0" indent="0" marL="0">
-                        <a:buNone/>
-                      </a:pPr>
-                      <a:r>
-                        <a:rPr/>
-                        <a:t>React + TypeScript + Tailwind · 3 trang</a:t>
-                      </a:r>
-                    </a:p>
-                  </a:txBody>
-                </a:tc>
-              </a:tr>
-              <a:tr h="0">
-                <a:tc>
-                  <a:txBody>
-                    <a:bodyPr/>
-                    <a:lstStyle/>
-                    <a:p>
-                      <a:pPr lvl="0" indent="0" marL="0">
-                        <a:buNone/>
-                      </a:pPr>
-                      <a:r>
-                        <a:rPr/>
-                        <a:t>L2 — API</a:t>
-                      </a:r>
-                    </a:p>
-                  </a:txBody>
-                </a:tc>
-                <a:tc>
-                  <a:txBody>
-                    <a:bodyPr/>
-                    <a:lstStyle/>
-                    <a:p>
-                      <a:pPr lvl="0" indent="0" marL="0">
-                        <a:buNone/>
-                      </a:pPr>
-                      <a:r>
-                        <a:rPr/>
-                        <a:t>FastAPI + Swagger · 10 endpoint</a:t>
-                      </a:r>
-                    </a:p>
-                  </a:txBody>
-                </a:tc>
-              </a:tr>
-              <a:tr h="0">
-                <a:tc>
-                  <a:txBody>
-                    <a:bodyPr/>
-                    <a:lstStyle/>
-                    <a:p>
-                      <a:pPr lvl="0" indent="0" marL="0">
-                        <a:buNone/>
-                      </a:pPr>
-                      <a:r>
-                        <a:rPr/>
-                        <a:t>L3 — Nghiệp vụ</a:t>
-                      </a:r>
-                    </a:p>
-                  </a:txBody>
-                </a:tc>
-                <a:tc>
-                  <a:txBody>
-                    <a:bodyPr/>
-                    <a:lstStyle/>
-                    <a:p>
-                      <a:pPr lvl="0" indent="0" marL="0">
-                        <a:buNone/>
-                      </a:pPr>
-                      <a:r>
-                        <a:rPr/>
-                        <a:t>Detection / Video / History / Storage</a:t>
-                      </a:r>
-                    </a:p>
-                  </a:txBody>
-                </a:tc>
-              </a:tr>
-              <a:tr h="0">
-                <a:tc>
-                  <a:txBody>
-                    <a:bodyPr/>
-                    <a:lstStyle/>
-                    <a:p>
-                      <a:pPr lvl="0" indent="0" marL="0">
-                        <a:buNone/>
-                      </a:pPr>
-                      <a:r>
-                        <a:rPr b="1"/>
-                        <a:t>L4 — AI</a:t>
-                      </a:r>
-                    </a:p>
-                  </a:txBody>
-                </a:tc>
-                <a:tc>
-                  <a:txBody>
-                    <a:bodyPr/>
-                    <a:lstStyle/>
-                    <a:p>
-                      <a:pPr lvl="0" indent="0" marL="0">
-                        <a:buNone/>
-                      </a:pPr>
-                      <a:r>
-                        <a:rPr b="1"/>
-                        <a:t>Python thuần</a:t>
-                      </a:r>
-                      <a:r>
-                        <a:rPr/>
-                        <a:t> — YOLO11 + PaddleOCR + Normalizer</a:t>
-                      </a:r>
-                    </a:p>
-                  </a:txBody>
-                </a:tc>
-              </a:tr>
-              <a:tr h="0">
-                <a:tc>
-                  <a:txBody>
-                    <a:bodyPr/>
-                    <a:lstStyle/>
-                    <a:p>
-                      <a:pPr lvl="0" indent="0" marL="0">
-                        <a:buNone/>
-                      </a:pPr>
-                      <a:r>
-                        <a:rPr/>
-                        <a:t>L5 — Dữ liệu</a:t>
-                      </a:r>
-                    </a:p>
-                  </a:txBody>
-                </a:tc>
-                <a:tc>
-                  <a:txBody>
-                    <a:bodyPr/>
-                    <a:lstStyle/>
-                    <a:p>
-                      <a:pPr lvl="0" indent="0" marL="0">
-                        <a:buNone/>
-                      </a:pPr>
-                      <a:r>
-                        <a:rPr/>
-                        <a:t>SQLite + SQLAlchemy + Alembic</a:t>
-                      </a:r>
-                    </a:p>
-                  </a:txBody>
-                </a:tc>
-              </a:tr>
-            </a:tbl>
-          </a:graphicData>
-        </a:graphic>
-      </p:graphicFrame>
-      <p:sp>
-        <p:nvSpPr>
-          <p:cNvPr id="449" name="Google Shape;449;p31"/>
-          <p:cNvSpPr txBox="1"/>
-          <p:nvPr>
-            <p:ph idx="12" type="sldNum"/>
-          </p:nvPr>
-        </p:nvSpPr>
-        <p:spPr>
-          <a:xfrm>
-            <a:off x="58380" y="6508358"/>
-            <a:ext cx="349642" cy="349642"/>
-          </a:xfrm>
-          <a:prstGeom prst="rect">
-            <a:avLst/>
-          </a:prstGeom>
-          <a:noFill/>
-          <a:ln>
-            <a:noFill/>
-          </a:ln>
-        </p:spPr>
-        <p:txBody>
-          <a:bodyPr anchor="ctr" anchorCtr="0" bIns="45700" lIns="91425" rIns="91425" spcFirstLastPara="1" tIns="45700" wrap="square">
-            <a:noAutofit/>
-          </a:bodyPr>
-          <a:lstStyle>
-            <a:lvl1pPr algn="ctr" indent="0" lvl="0" marL="0">
-              <a:spcBef>
-                <a:spcPts val="0"/>
-              </a:spcBef>
-              <a:buNone/>
-              <a:defRPr sz="700">
-                <a:solidFill>
-                  <a:schemeClr val="dk1"/>
-                </a:solidFill>
-                <a:latin typeface="Arial"/>
-                <a:ea typeface="Arial"/>
-                <a:cs typeface="Arial"/>
-                <a:sym typeface="Arial"/>
-              </a:defRPr>
-            </a:lvl1pPr>
-            <a:lvl2pPr algn="ctr" indent="0" lvl="1" marL="0">
-              <a:spcBef>
-                <a:spcPts val="0"/>
-              </a:spcBef>
-              <a:buNone/>
-              <a:defRPr sz="700">
-                <a:solidFill>
-                  <a:schemeClr val="dk1"/>
-                </a:solidFill>
-                <a:latin typeface="Arial"/>
-                <a:ea typeface="Arial"/>
-                <a:cs typeface="Arial"/>
-                <a:sym typeface="Arial"/>
-              </a:defRPr>
-            </a:lvl2pPr>
-            <a:lvl3pPr algn="ctr" indent="0" lvl="2" marL="0">
-              <a:spcBef>
-                <a:spcPts val="0"/>
-              </a:spcBef>
-              <a:buNone/>
-              <a:defRPr sz="700">
-                <a:solidFill>
-                  <a:schemeClr val="dk1"/>
-                </a:solidFill>
-                <a:latin typeface="Arial"/>
-                <a:ea typeface="Arial"/>
-                <a:cs typeface="Arial"/>
-                <a:sym typeface="Arial"/>
-              </a:defRPr>
-            </a:lvl3pPr>
-            <a:lvl4pPr algn="ctr" indent="0" lvl="3" marL="0">
-              <a:spcBef>
-                <a:spcPts val="0"/>
-              </a:spcBef>
-              <a:buNone/>
-              <a:defRPr sz="700">
-                <a:solidFill>
-                  <a:schemeClr val="dk1"/>
-                </a:solidFill>
-                <a:latin typeface="Arial"/>
-                <a:ea typeface="Arial"/>
-                <a:cs typeface="Arial"/>
-                <a:sym typeface="Arial"/>
-              </a:defRPr>
-            </a:lvl4pPr>
-            <a:lvl5pPr algn="ctr" indent="0" lvl="4" marL="0">
-              <a:spcBef>
-                <a:spcPts val="0"/>
-              </a:spcBef>
-              <a:buNone/>
-              <a:defRPr sz="700">
-                <a:solidFill>
-                  <a:schemeClr val="dk1"/>
-                </a:solidFill>
-                <a:latin typeface="Arial"/>
-                <a:ea typeface="Arial"/>
-                <a:cs typeface="Arial"/>
-                <a:sym typeface="Arial"/>
-              </a:defRPr>
-            </a:lvl5pPr>
-            <a:lvl6pPr algn="ctr" indent="0" lvl="5" marL="0">
-              <a:spcBef>
-                <a:spcPts val="0"/>
-              </a:spcBef>
-              <a:buNone/>
-              <a:defRPr sz="700">
-                <a:solidFill>
-                  <a:schemeClr val="dk1"/>
-                </a:solidFill>
-                <a:latin typeface="Arial"/>
-                <a:ea typeface="Arial"/>
-                <a:cs typeface="Arial"/>
-                <a:sym typeface="Arial"/>
-              </a:defRPr>
-            </a:lvl6pPr>
-            <a:lvl7pPr algn="ctr" indent="0" lvl="6" marL="0">
-              <a:spcBef>
-                <a:spcPts val="0"/>
-              </a:spcBef>
-              <a:buNone/>
-              <a:defRPr sz="700">
-                <a:solidFill>
-                  <a:schemeClr val="dk1"/>
-                </a:solidFill>
-                <a:latin typeface="Arial"/>
-                <a:ea typeface="Arial"/>
-                <a:cs typeface="Arial"/>
-                <a:sym typeface="Arial"/>
-              </a:defRPr>
-            </a:lvl7pPr>
-            <a:lvl8pPr algn="ctr" indent="0" lvl="7" marL="0">
-              <a:spcBef>
-                <a:spcPts val="0"/>
-              </a:spcBef>
-              <a:buNone/>
-              <a:defRPr sz="700">
-                <a:solidFill>
-                  <a:schemeClr val="dk1"/>
-                </a:solidFill>
-                <a:latin typeface="Arial"/>
-                <a:ea typeface="Arial"/>
-                <a:cs typeface="Arial"/>
-                <a:sym typeface="Arial"/>
-              </a:defRPr>
-            </a:lvl8pPr>
-            <a:lvl9pPr algn="ctr" indent="0" lvl="8" marL="0">
-              <a:spcBef>
-                <a:spcPts val="0"/>
-              </a:spcBef>
-              <a:buNone/>
-              <a:defRPr sz="700">
-                <a:solidFill>
-                  <a:schemeClr val="dk1"/>
-                </a:solidFill>
-                <a:latin typeface="Arial"/>
-                <a:ea typeface="Arial"/>
-                <a:cs typeface="Arial"/>
-                <a:sym typeface="Arial"/>
-              </a:defRPr>
-            </a:lvl9pPr>
-          </a:lstStyle>
-          <a:p>
-            <a:pPr algn="ctr" indent="0" lvl="0" marL="0" rtl="0">
-              <a:spcBef>
-                <a:spcPts val="0"/>
-              </a:spcBef>
-              <a:spcAft>
-                <a:spcPts val="0"/>
-              </a:spcAft>
-              <a:buNone/>
-            </a:pPr>
-            <a:fld id="{00000000-1234-1234-1234-123412341234}" type="slidenum">
-              <a:rPr lang="en-US"/>
-              <a:t>‹#›</a:t>
-            </a:fld>
-            <a:endParaRPr/>
-          </a:p>
-        </p:txBody>
-      </p:sp>
-    </p:spTree>
-  </p:cSld>
-</p:sld>
-</file>
-
-<file path=ppt/slides/slide11.xml><?xml version="1.0" encoding="utf-8"?>
-<p:sld xmlns:a="http://schemas.openxmlformats.org/drawingml/2006/main" xmlns:r="http://schemas.openxmlformats.org/officeDocument/2006/relationships" xmlns:p="http://schemas.openxmlformats.org/presentationml/2006/main">
-  <p:cSld>
-    <p:spTree>
-      <p:nvGrpSpPr>
-        <p:cNvPr id="428" name="Shape 428"/>
-        <p:cNvGrpSpPr/>
-        <p:nvPr/>
-      </p:nvGrpSpPr>
-      <p:grpSpPr>
-        <a:xfrm>
-          <a:off x="0" y="0"/>
-          <a:ext cx="0" cy="0"/>
-          <a:chOff x="0" y="0"/>
-          <a:chExt cx="0" cy="0"/>
-        </a:xfrm>
-      </p:grpSpPr>
-      <p:sp>
-        <p:nvSpPr>
-          <p:cNvPr id="436" name="Google Shape;436;p31"/>
-          <p:cNvSpPr txBox="1"/>
-          <p:nvPr>
-            <p:ph type="title"/>
-          </p:nvPr>
-        </p:nvSpPr>
-        <p:spPr>
-          <a:xfrm>
-            <a:off x="774146" y="202009"/>
-            <a:ext cx="3932227" cy="1698043"/>
-          </a:xfrm>
-          <a:prstGeom prst="rect">
-            <a:avLst/>
-          </a:prstGeom>
-          <a:noFill/>
-          <a:ln>
-            <a:noFill/>
-          </a:ln>
-        </p:spPr>
-        <p:txBody>
-          <a:bodyPr/>
-          <a:lstStyle/>
-          <a:p>
-            <a:pPr lvl="0" indent="0" marL="0">
-              <a:buNone/>
-            </a:pPr>
-            <a:r>
-              <a:rPr/>
-              <a:t>Cơ sở dữ liệu — một cột làm nên đóng góp</a:t>
-            </a:r>
-          </a:p>
-        </p:txBody>
-      </p:sp>
-      <p:sp>
-        <p:nvSpPr>
-          <p:cNvPr id="437" name="Google Shape;437;p31"/>
-          <p:cNvSpPr txBox="1"/>
-          <p:nvPr>
-            <p:ph idx="2" sz="half" type="body"/>
-          </p:nvPr>
-        </p:nvSpPr>
-        <p:spPr/>
-        <p:txBody>
-          <a:bodyPr/>
-          <a:lstStyle/>
-          <a:p>
-            <a:pPr lvl="0" indent="0" marL="0">
-              <a:buNone/>
-            </a:pPr>
-            <a:r>
-              <a:rPr/>
-              <a:t>Bảng </a:t>
-            </a:r>
-            <a:r>
-              <a:rPr>
-                <a:latin typeface="Courier"/>
-              </a:rPr>
-              <a:t>detection_history</a:t>
-            </a:r>
-            <a:r>
-              <a:rPr/>
-              <a:t> lưu </a:t>
-            </a:r>
-            <a:r>
-              <a:rPr b="1"/>
-              <a:t>cả hai</a:t>
-            </a:r>
-            <a:r>
-              <a:rPr/>
-              <a:t> chuỗi trên </a:t>
-            </a:r>
-            <a:r>
-              <a:rPr b="1"/>
-              <a:t>cùng một bản ghi</a:t>
-            </a:r>
-          </a:p>
-        </p:txBody>
-      </p:sp>
-      <p:graphicFrame>
-        <p:nvGraphicFramePr>
-          <p:cNvPr id="6" name="Content Placeholder 5"/>
-          <p:cNvGraphicFramePr>
-            <a:graphicFrameLocks noGrp="1"/>
-          </p:cNvGraphicFramePr>
-          <p:nvPr>
-            <p:ph idx="1"/>
-          </p:nvPr>
-        </p:nvGraphicFramePr>
-        <p:xfrm>
-          <a:off x="5156200" y="190500"/>
-          <a:ext cx="6235700" cy="5969000"/>
-        </p:xfrm>
-        <a:graphic>
-          <a:graphicData uri="http://schemas.openxmlformats.org/drawingml/2006/table">
-            <a:tbl>
-              <a:tblPr firstRow="1" bandRow="1">
-                <a:tableStyleId>{45BEF19B-5B1D-4A26-B267-ECC71EF7E2D4}</a:tableStyleId>
-              </a:tblPr>
-              <a:tblGrid>
-                <a:gridCol w="3111500"/>
-                <a:gridCol w="3111500"/>
-              </a:tblGrid>
-              <a:tr h="0">
-                <a:tc>
-                  <a:txBody>
-                    <a:bodyPr/>
-                    <a:lstStyle/>
-                    <a:p>
-                      <a:pPr lvl="0" indent="0" marL="0">
-                        <a:buNone/>
-                      </a:pPr>
-                      <a:r>
-                        <a:rPr/>
-                        <a:t>Cột</a:t>
-                      </a:r>
-                    </a:p>
-                  </a:txBody>
-                  <a:tcPr/>
-                </a:tc>
-                <a:tc>
-                  <a:txBody>
-                    <a:bodyPr/>
-                    <a:lstStyle/>
-                    <a:p>
-                      <a:pPr lvl="0" indent="0" marL="0">
-                        <a:buNone/>
-                      </a:pPr>
-                      <a:r>
-                        <a:rPr/>
-                        <a:t>Nội dung</a:t>
-                      </a:r>
-                    </a:p>
-                  </a:txBody>
-                  <a:tcPr/>
-                </a:tc>
-              </a:tr>
-              <a:tr h="0">
-                <a:tc>
-                  <a:txBody>
-                    <a:bodyPr/>
-                    <a:lstStyle/>
-                    <a:p>
-                      <a:pPr lvl="0" indent="0" marL="0">
-                        <a:buNone/>
-                      </a:pPr>
-                      <a:r>
-                        <a:rPr>
-                          <a:latin typeface="Courier"/>
-                        </a:rPr>
-                        <a:t>raw_ocr_text</a:t>
-                      </a:r>
-                    </a:p>
-                  </a:txBody>
-                </a:tc>
-                <a:tc>
-                  <a:txBody>
-                    <a:bodyPr/>
-                    <a:lstStyle/>
-                    <a:p>
-                      <a:pPr lvl="0" indent="0" marL="0">
-                        <a:buNone/>
-                      </a:pPr>
-                      <a:r>
-                        <a:rPr/>
-                        <a:t>Chuỗi </a:t>
-                      </a:r>
-                      <a:r>
-                        <a:rPr b="1"/>
-                        <a:t>thô</a:t>
-                      </a:r>
-                      <a:r>
-                        <a:rPr/>
-                        <a:t> do PaddleOCR trả về</a:t>
-                      </a:r>
-                    </a:p>
-                  </a:txBody>
-                </a:tc>
-              </a:tr>
-              <a:tr h="0">
-                <a:tc>
-                  <a:txBody>
-                    <a:bodyPr/>
-                    <a:lstStyle/>
-                    <a:p>
-                      <a:pPr lvl="0" indent="0" marL="0">
-                        <a:buNone/>
-                      </a:pPr>
-                      <a:r>
-                        <a:rPr>
-                          <a:latin typeface="Courier"/>
-                        </a:rPr>
-                        <a:t>plate_number</a:t>
-                      </a:r>
-                    </a:p>
-                  </a:txBody>
-                </a:tc>
-                <a:tc>
-                  <a:txBody>
-                    <a:bodyPr/>
-                    <a:lstStyle/>
-                    <a:p>
-                      <a:pPr lvl="0" indent="0" marL="0">
-                        <a:buNone/>
-                      </a:pPr>
-                      <a:r>
-                        <a:rPr/>
-                        <a:t>Chuỗi </a:t>
-                      </a:r>
-                      <a:r>
-                        <a:rPr b="1"/>
-                        <a:t>sau</a:t>
-                      </a:r>
-                      <a:r>
-                        <a:rPr/>
-                        <a:t> bộ luật hậu xử lý</a:t>
-                      </a:r>
-                    </a:p>
-                  </a:txBody>
-                </a:tc>
-              </a:tr>
-              <a:tr h="0">
-                <a:tc>
-                  <a:txBody>
-                    <a:bodyPr/>
-                    <a:lstStyle/>
-                    <a:p>
-                      <a:pPr lvl="0" indent="0" marL="0">
-                        <a:buNone/>
-                      </a:pPr>
-                      <a:r>
-                        <a:rPr>
-                          <a:latin typeface="Courier"/>
-                        </a:rPr>
-                        <a:t>is_valid_format</a:t>
-                      </a:r>
-                    </a:p>
-                  </a:txBody>
-                </a:tc>
-                <a:tc>
-                  <a:txBody>
-                    <a:bodyPr/>
-                    <a:lstStyle/>
-                    <a:p>
-                      <a:pPr lvl="0" indent="0" marL="0">
-                        <a:buNone/>
-                      </a:pPr>
-                      <a:r>
-                        <a:rPr/>
-                        <a:t>Hợp quy cách Việt Nam hay không</a:t>
-                      </a:r>
-                    </a:p>
-                  </a:txBody>
-                </a:tc>
-              </a:tr>
-            </a:tbl>
-          </a:graphicData>
-        </a:graphic>
-      </p:graphicFrame>
-      <p:sp>
-        <p:nvSpPr>
-          <p:cNvPr id="449" name="Google Shape;449;p31"/>
-          <p:cNvSpPr txBox="1"/>
-          <p:nvPr>
-            <p:ph idx="12" type="sldNum"/>
-          </p:nvPr>
-        </p:nvSpPr>
-        <p:spPr>
-          <a:xfrm>
-            <a:off x="58380" y="6508358"/>
-            <a:ext cx="349642" cy="349642"/>
-          </a:xfrm>
-          <a:prstGeom prst="rect">
-            <a:avLst/>
-          </a:prstGeom>
-          <a:noFill/>
-          <a:ln>
-            <a:noFill/>
-          </a:ln>
-        </p:spPr>
-        <p:txBody>
-          <a:bodyPr anchor="ctr" anchorCtr="0" bIns="45700" lIns="91425" rIns="91425" spcFirstLastPara="1" tIns="45700" wrap="square">
-            <a:noAutofit/>
-          </a:bodyPr>
-          <a:lstStyle>
-            <a:lvl1pPr algn="ctr" indent="0" lvl="0" marL="0">
-              <a:spcBef>
-                <a:spcPts val="0"/>
-              </a:spcBef>
-              <a:buNone/>
-              <a:defRPr sz="700">
-                <a:solidFill>
-                  <a:schemeClr val="dk1"/>
-                </a:solidFill>
-                <a:latin typeface="Arial"/>
-                <a:ea typeface="Arial"/>
-                <a:cs typeface="Arial"/>
-                <a:sym typeface="Arial"/>
-              </a:defRPr>
-            </a:lvl1pPr>
-            <a:lvl2pPr algn="ctr" indent="0" lvl="1" marL="0">
-              <a:spcBef>
-                <a:spcPts val="0"/>
-              </a:spcBef>
-              <a:buNone/>
-              <a:defRPr sz="700">
-                <a:solidFill>
-                  <a:schemeClr val="dk1"/>
-                </a:solidFill>
-                <a:latin typeface="Arial"/>
-                <a:ea typeface="Arial"/>
-                <a:cs typeface="Arial"/>
-                <a:sym typeface="Arial"/>
-              </a:defRPr>
-            </a:lvl2pPr>
-            <a:lvl3pPr algn="ctr" indent="0" lvl="2" marL="0">
-              <a:spcBef>
-                <a:spcPts val="0"/>
-              </a:spcBef>
-              <a:buNone/>
-              <a:defRPr sz="700">
-                <a:solidFill>
-                  <a:schemeClr val="dk1"/>
-                </a:solidFill>
-                <a:latin typeface="Arial"/>
-                <a:ea typeface="Arial"/>
-                <a:cs typeface="Arial"/>
-                <a:sym typeface="Arial"/>
-              </a:defRPr>
-            </a:lvl3pPr>
-            <a:lvl4pPr algn="ctr" indent="0" lvl="3" marL="0">
-              <a:spcBef>
-                <a:spcPts val="0"/>
-              </a:spcBef>
-              <a:buNone/>
-              <a:defRPr sz="700">
-                <a:solidFill>
-                  <a:schemeClr val="dk1"/>
-                </a:solidFill>
-                <a:latin typeface="Arial"/>
-                <a:ea typeface="Arial"/>
-                <a:cs typeface="Arial"/>
-                <a:sym typeface="Arial"/>
-              </a:defRPr>
-            </a:lvl4pPr>
-            <a:lvl5pPr algn="ctr" indent="0" lvl="4" marL="0">
-              <a:spcBef>
-                <a:spcPts val="0"/>
-              </a:spcBef>
-              <a:buNone/>
-              <a:defRPr sz="700">
-                <a:solidFill>
-                  <a:schemeClr val="dk1"/>
-                </a:solidFill>
-                <a:latin typeface="Arial"/>
-                <a:ea typeface="Arial"/>
-                <a:cs typeface="Arial"/>
-                <a:sym typeface="Arial"/>
-              </a:defRPr>
-            </a:lvl5pPr>
-            <a:lvl6pPr algn="ctr" indent="0" lvl="5" marL="0">
-              <a:spcBef>
-                <a:spcPts val="0"/>
-              </a:spcBef>
-              <a:buNone/>
-              <a:defRPr sz="700">
-                <a:solidFill>
-                  <a:schemeClr val="dk1"/>
-                </a:solidFill>
-                <a:latin typeface="Arial"/>
-                <a:ea typeface="Arial"/>
-                <a:cs typeface="Arial"/>
-                <a:sym typeface="Arial"/>
-              </a:defRPr>
-            </a:lvl6pPr>
-            <a:lvl7pPr algn="ctr" indent="0" lvl="6" marL="0">
-              <a:spcBef>
-                <a:spcPts val="0"/>
-              </a:spcBef>
-              <a:buNone/>
-              <a:defRPr sz="700">
-                <a:solidFill>
-                  <a:schemeClr val="dk1"/>
-                </a:solidFill>
-                <a:latin typeface="Arial"/>
-                <a:ea typeface="Arial"/>
-                <a:cs typeface="Arial"/>
-                <a:sym typeface="Arial"/>
-              </a:defRPr>
-            </a:lvl7pPr>
-            <a:lvl8pPr algn="ctr" indent="0" lvl="7" marL="0">
-              <a:spcBef>
-                <a:spcPts val="0"/>
-              </a:spcBef>
-              <a:buNone/>
-              <a:defRPr sz="700">
-                <a:solidFill>
-                  <a:schemeClr val="dk1"/>
-                </a:solidFill>
-                <a:latin typeface="Arial"/>
-                <a:ea typeface="Arial"/>
-                <a:cs typeface="Arial"/>
-                <a:sym typeface="Arial"/>
-              </a:defRPr>
-            </a:lvl8pPr>
-            <a:lvl9pPr algn="ctr" indent="0" lvl="8" marL="0">
-              <a:spcBef>
-                <a:spcPts val="0"/>
-              </a:spcBef>
-              <a:buNone/>
-              <a:defRPr sz="700">
-                <a:solidFill>
-                  <a:schemeClr val="dk1"/>
-                </a:solidFill>
-                <a:latin typeface="Arial"/>
-                <a:ea typeface="Arial"/>
-                <a:cs typeface="Arial"/>
-                <a:sym typeface="Arial"/>
-              </a:defRPr>
-            </a:lvl9pPr>
-          </a:lstStyle>
-          <a:p>
-            <a:pPr algn="ctr" indent="0" lvl="0" marL="0" rtl="0">
-              <a:spcBef>
-                <a:spcPts val="0"/>
-              </a:spcBef>
-              <a:spcAft>
-                <a:spcPts val="0"/>
-              </a:spcAft>
-              <a:buNone/>
-            </a:pPr>
-            <a:fld id="{00000000-1234-1234-1234-123412341234}" type="slidenum">
-              <a:rPr lang="en-US"/>
-              <a:t>‹#›</a:t>
-            </a:fld>
-            <a:endParaRPr/>
-          </a:p>
-        </p:txBody>
-      </p:sp>
-    </p:spTree>
-  </p:cSld>
-</p:sld>
-</file>
-
-<file path=ppt/slides/slide12.xml><?xml version="1.0" encoding="utf-8"?>
-<p:sld xmlns:a="http://schemas.openxmlformats.org/drawingml/2006/main" xmlns:r="http://schemas.openxmlformats.org/officeDocument/2006/relationships" xmlns:p="http://schemas.openxmlformats.org/presentationml/2006/main">
-  <p:cSld>
-    <p:spTree>
-      <p:nvGrpSpPr>
-        <p:cNvPr id="134" name="Shape 134"/>
-        <p:cNvGrpSpPr/>
-        <p:nvPr/>
-      </p:nvGrpSpPr>
-      <p:grpSpPr>
-        <a:xfrm>
-          <a:off x="0" y="0"/>
-          <a:ext cx="0" cy="0"/>
-          <a:chOff x="0" y="0"/>
-          <a:chExt cx="0" cy="0"/>
-        </a:xfrm>
-      </p:grpSpPr>
-      <p:sp>
-        <p:nvSpPr>
-          <p:cNvPr id="143" name="Google Shape;143;p23"/>
-          <p:cNvSpPr txBox="1"/>
-          <p:nvPr>
-            <p:ph idx="1"/>
-          </p:nvPr>
-        </p:nvSpPr>
-        <p:spPr/>
-        <p:txBody>
-          <a:bodyPr/>
-          <a:lstStyle/>
-          <a:p>
-            <a:pPr lvl="0" indent="0" marL="0">
-              <a:buNone/>
-            </a:pPr>
-            <a:r>
-              <a:rPr/>
-              <a:t>⇒ Không có cột </a:t>
-            </a:r>
-            <a:r>
-              <a:rPr>
-                <a:latin typeface="Courier"/>
-              </a:rPr>
-              <a:t>raw_ocr_text</a:t>
-            </a:r>
-            <a:r>
-              <a:rPr/>
-              <a:t> thì </a:t>
-            </a:r>
-            <a:r>
-              <a:rPr b="1"/>
-              <a:t>không đo được</a:t>
-            </a:r>
-            <a:r>
-              <a:rPr/>
-              <a:t> đóng góp của hậu xử lý. Đây là quyết định thiết kế từ Phase 0, không phải cột gỡ lỗi thừa</a:t>
-            </a:r>
-          </a:p>
-        </p:txBody>
-      </p:sp>
-      <p:sp>
-        <p:nvSpPr>
-          <p:cNvPr id="155" name="Google Shape;155;p23"/>
-          <p:cNvSpPr txBox="1"/>
-          <p:nvPr>
-            <p:ph idx="12" type="sldNum"/>
-          </p:nvPr>
-        </p:nvSpPr>
-        <p:spPr>
-          <a:xfrm>
-            <a:off x="58380" y="6508358"/>
-            <a:ext cx="349642" cy="349642"/>
-          </a:xfrm>
-          <a:prstGeom prst="rect">
-            <a:avLst/>
-          </a:prstGeom>
-          <a:noFill/>
-          <a:ln>
-            <a:noFill/>
-          </a:ln>
-        </p:spPr>
-        <p:txBody>
-          <a:bodyPr anchor="ctr" anchorCtr="0" bIns="45700" lIns="91425" rIns="91425" spcFirstLastPara="1" tIns="45700" wrap="square">
-            <a:noAutofit/>
-          </a:bodyPr>
-          <a:lstStyle>
-            <a:lvl1pPr algn="ctr" indent="0" lvl="0" marL="0">
-              <a:spcBef>
-                <a:spcPts val="0"/>
-              </a:spcBef>
-              <a:buNone/>
-              <a:defRPr sz="700">
-                <a:solidFill>
-                  <a:schemeClr val="dk1"/>
-                </a:solidFill>
-                <a:latin typeface="Arial"/>
-                <a:ea typeface="Arial"/>
-                <a:cs typeface="Arial"/>
-                <a:sym typeface="Arial"/>
-              </a:defRPr>
-            </a:lvl1pPr>
-            <a:lvl2pPr algn="ctr" indent="0" lvl="1" marL="0">
-              <a:spcBef>
-                <a:spcPts val="0"/>
-              </a:spcBef>
-              <a:buNone/>
-              <a:defRPr sz="700">
-                <a:solidFill>
-                  <a:schemeClr val="dk1"/>
-                </a:solidFill>
-                <a:latin typeface="Arial"/>
-                <a:ea typeface="Arial"/>
-                <a:cs typeface="Arial"/>
-                <a:sym typeface="Arial"/>
-              </a:defRPr>
-            </a:lvl2pPr>
-            <a:lvl3pPr algn="ctr" indent="0" lvl="2" marL="0">
-              <a:spcBef>
-                <a:spcPts val="0"/>
-              </a:spcBef>
-              <a:buNone/>
-              <a:defRPr sz="700">
-                <a:solidFill>
-                  <a:schemeClr val="dk1"/>
-                </a:solidFill>
-                <a:latin typeface="Arial"/>
-                <a:ea typeface="Arial"/>
-                <a:cs typeface="Arial"/>
-                <a:sym typeface="Arial"/>
-              </a:defRPr>
-            </a:lvl3pPr>
-            <a:lvl4pPr algn="ctr" indent="0" lvl="3" marL="0">
-              <a:spcBef>
-                <a:spcPts val="0"/>
-              </a:spcBef>
-              <a:buNone/>
-              <a:defRPr sz="700">
-                <a:solidFill>
-                  <a:schemeClr val="dk1"/>
-                </a:solidFill>
-                <a:latin typeface="Arial"/>
-                <a:ea typeface="Arial"/>
-                <a:cs typeface="Arial"/>
-                <a:sym typeface="Arial"/>
-              </a:defRPr>
-            </a:lvl4pPr>
-            <a:lvl5pPr algn="ctr" indent="0" lvl="4" marL="0">
-              <a:spcBef>
-                <a:spcPts val="0"/>
-              </a:spcBef>
-              <a:buNone/>
-              <a:defRPr sz="700">
-                <a:solidFill>
-                  <a:schemeClr val="dk1"/>
-                </a:solidFill>
-                <a:latin typeface="Arial"/>
-                <a:ea typeface="Arial"/>
-                <a:cs typeface="Arial"/>
-                <a:sym typeface="Arial"/>
-              </a:defRPr>
-            </a:lvl5pPr>
-            <a:lvl6pPr algn="ctr" indent="0" lvl="5" marL="0">
-              <a:spcBef>
-                <a:spcPts val="0"/>
-              </a:spcBef>
-              <a:buNone/>
-              <a:defRPr sz="700">
-                <a:solidFill>
-                  <a:schemeClr val="dk1"/>
-                </a:solidFill>
-                <a:latin typeface="Arial"/>
-                <a:ea typeface="Arial"/>
-                <a:cs typeface="Arial"/>
-                <a:sym typeface="Arial"/>
-              </a:defRPr>
-            </a:lvl6pPr>
-            <a:lvl7pPr algn="ctr" indent="0" lvl="6" marL="0">
-              <a:spcBef>
-                <a:spcPts val="0"/>
-              </a:spcBef>
-              <a:buNone/>
-              <a:defRPr sz="700">
-                <a:solidFill>
-                  <a:schemeClr val="dk1"/>
-                </a:solidFill>
-                <a:latin typeface="Arial"/>
-                <a:ea typeface="Arial"/>
-                <a:cs typeface="Arial"/>
-                <a:sym typeface="Arial"/>
-              </a:defRPr>
-            </a:lvl7pPr>
-            <a:lvl8pPr algn="ctr" indent="0" lvl="7" marL="0">
-              <a:spcBef>
-                <a:spcPts val="0"/>
-              </a:spcBef>
-              <a:buNone/>
-              <a:defRPr sz="700">
-                <a:solidFill>
-                  <a:schemeClr val="dk1"/>
-                </a:solidFill>
-                <a:latin typeface="Arial"/>
-                <a:ea typeface="Arial"/>
-                <a:cs typeface="Arial"/>
-                <a:sym typeface="Arial"/>
-              </a:defRPr>
-            </a:lvl8pPr>
-            <a:lvl9pPr algn="ctr" indent="0" lvl="8" marL="0">
-              <a:spcBef>
-                <a:spcPts val="0"/>
-              </a:spcBef>
-              <a:buNone/>
-              <a:defRPr sz="700">
-                <a:solidFill>
-                  <a:schemeClr val="dk1"/>
-                </a:solidFill>
-                <a:latin typeface="Arial"/>
-                <a:ea typeface="Arial"/>
-                <a:cs typeface="Arial"/>
-                <a:sym typeface="Arial"/>
-              </a:defRPr>
-            </a:lvl9pPr>
-          </a:lstStyle>
-          <a:p>
-            <a:pPr algn="ctr" indent="0" lvl="0" marL="0" rtl="0">
-              <a:spcBef>
-                <a:spcPts val="0"/>
-              </a:spcBef>
-              <a:spcAft>
-                <a:spcPts val="0"/>
-              </a:spcAft>
-              <a:buNone/>
-            </a:pPr>
-            <a:fld id="{00000000-1234-1234-1234-123412341234}" type="slidenum">
-              <a:rPr lang="en-US"/>
-              <a:t>‹#›</a:t>
-            </a:fld>
-            <a:endParaRPr/>
-          </a:p>
-        </p:txBody>
-      </p:sp>
-    </p:spTree>
-  </p:cSld>
-</p:sld>
-</file>
-
-<file path=ppt/slides/slide13.xml><?xml version="1.0" encoding="utf-8"?>
-<p:sld xmlns:a="http://schemas.openxmlformats.org/drawingml/2006/main" xmlns:r="http://schemas.openxmlformats.org/officeDocument/2006/relationships" xmlns:p="http://schemas.openxmlformats.org/presentationml/2006/main">
-  <p:cSld>
-    <p:spTree>
-      <p:nvGrpSpPr>
         <p:cNvPr id="134" name="Shape 134"/>
         <p:cNvGrpSpPr/>
         <p:nvPr/>
@@ -45471,244 +44261,7 @@
 </p:sld>
 </file>
 
-<file path=ppt/slides/slide14.xml><?xml version="1.0" encoding="utf-8"?>
-<p:sld xmlns:a="http://schemas.openxmlformats.org/drawingml/2006/main" xmlns:r="http://schemas.openxmlformats.org/officeDocument/2006/relationships" xmlns:p="http://schemas.openxmlformats.org/presentationml/2006/main">
-  <p:cSld>
-    <p:spTree>
-      <p:nvGrpSpPr>
-        <p:cNvPr id="318" name="Shape 318"/>
-        <p:cNvGrpSpPr/>
-        <p:nvPr/>
-      </p:nvGrpSpPr>
-      <p:grpSpPr>
-        <a:xfrm>
-          <a:off x="0" y="0"/>
-          <a:ext cx="0" cy="0"/>
-          <a:chOff x="0" y="0"/>
-          <a:chExt cx="0" cy="0"/>
-        </a:xfrm>
-      </p:grpSpPr>
-      <p:sp>
-        <p:nvSpPr>
-          <p:cNvPr id="332" name="Google Shape;332;p28"/>
-          <p:cNvSpPr txBox="1"/>
-          <p:nvPr>
-            <p:ph type="title"/>
-          </p:nvPr>
-        </p:nvSpPr>
-        <p:spPr>
-          <a:xfrm>
-            <a:off x="1470929" y="2095027"/>
-            <a:ext cx="9941071" cy="884656"/>
-          </a:xfrm>
-          <a:prstGeom prst="rect">
-            <a:avLst/>
-          </a:prstGeom>
-          <a:noFill/>
-          <a:ln>
-            <a:noFill/>
-          </a:ln>
-        </p:spPr>
-        <p:txBody>
-          <a:bodyPr/>
-          <a:lstStyle/>
-          <a:p>
-            <a:pPr lvl="0" indent="0" marL="0">
-              <a:buNone/>
-            </a:pPr>
-            <a:r>
-              <a:rPr/>
-              <a:t>Dữ liệu và huấn luyện</a:t>
-            </a:r>
-          </a:p>
-        </p:txBody>
-      </p:sp>
-      <p:sp>
-        <p:nvSpPr>
-          <p:cNvPr id="347" name="Google Shape;347;p28"/>
-          <p:cNvSpPr txBox="1"/>
-          <p:nvPr>
-            <p:ph idx="12" type="sldNum"/>
-          </p:nvPr>
-        </p:nvSpPr>
-        <p:spPr>
-          <a:xfrm>
-            <a:off x="65862" y="6542216"/>
-            <a:ext cx="292608" cy="315784"/>
-          </a:xfrm>
-          <a:prstGeom prst="rect">
-            <a:avLst/>
-          </a:prstGeom>
-          <a:noFill/>
-          <a:ln>
-            <a:noFill/>
-          </a:ln>
-        </p:spPr>
-        <p:txBody>
-          <a:bodyPr anchor="ctr" anchorCtr="0" bIns="45700" lIns="91425" rIns="91425" spcFirstLastPara="1" tIns="45700" wrap="square">
-            <a:noAutofit/>
-          </a:bodyPr>
-          <a:lstStyle>
-            <a:lvl1pPr algn="ctr" indent="0" lvl="0" marL="0">
-              <a:spcBef>
-                <a:spcPts val="0"/>
-              </a:spcBef>
-              <a:buNone/>
-              <a:defRPr sz="700">
-                <a:solidFill>
-                  <a:schemeClr val="dk1"/>
-                </a:solidFill>
-                <a:latin typeface="Arial"/>
-                <a:ea typeface="Arial"/>
-                <a:cs typeface="Arial"/>
-                <a:sym typeface="Arial"/>
-              </a:defRPr>
-            </a:lvl1pPr>
-            <a:lvl2pPr algn="ctr" indent="0" lvl="1" marL="0">
-              <a:spcBef>
-                <a:spcPts val="0"/>
-              </a:spcBef>
-              <a:buNone/>
-              <a:defRPr sz="700">
-                <a:solidFill>
-                  <a:schemeClr val="dk1"/>
-                </a:solidFill>
-                <a:latin typeface="Arial"/>
-                <a:ea typeface="Arial"/>
-                <a:cs typeface="Arial"/>
-                <a:sym typeface="Arial"/>
-              </a:defRPr>
-            </a:lvl2pPr>
-            <a:lvl3pPr algn="ctr" indent="0" lvl="2" marL="0">
-              <a:spcBef>
-                <a:spcPts val="0"/>
-              </a:spcBef>
-              <a:buNone/>
-              <a:defRPr sz="700">
-                <a:solidFill>
-                  <a:schemeClr val="dk1"/>
-                </a:solidFill>
-                <a:latin typeface="Arial"/>
-                <a:ea typeface="Arial"/>
-                <a:cs typeface="Arial"/>
-                <a:sym typeface="Arial"/>
-              </a:defRPr>
-            </a:lvl3pPr>
-            <a:lvl4pPr algn="ctr" indent="0" lvl="3" marL="0">
-              <a:spcBef>
-                <a:spcPts val="0"/>
-              </a:spcBef>
-              <a:buNone/>
-              <a:defRPr sz="700">
-                <a:solidFill>
-                  <a:schemeClr val="dk1"/>
-                </a:solidFill>
-                <a:latin typeface="Arial"/>
-                <a:ea typeface="Arial"/>
-                <a:cs typeface="Arial"/>
-                <a:sym typeface="Arial"/>
-              </a:defRPr>
-            </a:lvl4pPr>
-            <a:lvl5pPr algn="ctr" indent="0" lvl="4" marL="0">
-              <a:spcBef>
-                <a:spcPts val="0"/>
-              </a:spcBef>
-              <a:buNone/>
-              <a:defRPr sz="700">
-                <a:solidFill>
-                  <a:schemeClr val="dk1"/>
-                </a:solidFill>
-                <a:latin typeface="Arial"/>
-                <a:ea typeface="Arial"/>
-                <a:cs typeface="Arial"/>
-                <a:sym typeface="Arial"/>
-              </a:defRPr>
-            </a:lvl5pPr>
-            <a:lvl6pPr algn="ctr" indent="0" lvl="5" marL="0">
-              <a:spcBef>
-                <a:spcPts val="0"/>
-              </a:spcBef>
-              <a:buNone/>
-              <a:defRPr sz="700">
-                <a:solidFill>
-                  <a:schemeClr val="dk1"/>
-                </a:solidFill>
-                <a:latin typeface="Arial"/>
-                <a:ea typeface="Arial"/>
-                <a:cs typeface="Arial"/>
-                <a:sym typeface="Arial"/>
-              </a:defRPr>
-            </a:lvl6pPr>
-            <a:lvl7pPr algn="ctr" indent="0" lvl="6" marL="0">
-              <a:spcBef>
-                <a:spcPts val="0"/>
-              </a:spcBef>
-              <a:buNone/>
-              <a:defRPr sz="700">
-                <a:solidFill>
-                  <a:schemeClr val="dk1"/>
-                </a:solidFill>
-                <a:latin typeface="Arial"/>
-                <a:ea typeface="Arial"/>
-                <a:cs typeface="Arial"/>
-                <a:sym typeface="Arial"/>
-              </a:defRPr>
-            </a:lvl7pPr>
-            <a:lvl8pPr algn="ctr" indent="0" lvl="7" marL="0">
-              <a:spcBef>
-                <a:spcPts val="0"/>
-              </a:spcBef>
-              <a:buNone/>
-              <a:defRPr sz="700">
-                <a:solidFill>
-                  <a:schemeClr val="dk1"/>
-                </a:solidFill>
-                <a:latin typeface="Arial"/>
-                <a:ea typeface="Arial"/>
-                <a:cs typeface="Arial"/>
-                <a:sym typeface="Arial"/>
-              </a:defRPr>
-            </a:lvl8pPr>
-            <a:lvl9pPr algn="ctr" indent="0" lvl="8" marL="0">
-              <a:spcBef>
-                <a:spcPts val="0"/>
-              </a:spcBef>
-              <a:buNone/>
-              <a:defRPr sz="700">
-                <a:solidFill>
-                  <a:schemeClr val="dk1"/>
-                </a:solidFill>
-                <a:latin typeface="Arial"/>
-                <a:ea typeface="Arial"/>
-                <a:cs typeface="Arial"/>
-                <a:sym typeface="Arial"/>
-              </a:defRPr>
-            </a:lvl9pPr>
-          </a:lstStyle>
-          <a:p>
-            <a:pPr algn="ctr" indent="0" lvl="0" marL="0" rtl="0">
-              <a:spcBef>
-                <a:spcPts val="0"/>
-              </a:spcBef>
-              <a:spcAft>
-                <a:spcPts val="0"/>
-              </a:spcAft>
-              <a:buNone/>
-            </a:pPr>
-            <a:fld id="{00000000-1234-1234-1234-123412341234}" type="slidenum">
-              <a:rPr lang="en-US"/>
-              <a:t>‹#›</a:t>
-            </a:fld>
-            <a:endParaRPr/>
-          </a:p>
-        </p:txBody>
-      </p:sp>
-    </p:spTree>
-  </p:cSld>
-</p:sld>
-</file>
-
-<file path=ppt/slides/slide15.xml><?xml version="1.0" encoding="utf-8"?>
+<file path=ppt/slides/slide11.xml><?xml version="1.0" encoding="utf-8"?>
 <p:sld xmlns:a="http://schemas.openxmlformats.org/drawingml/2006/main" xmlns:r="http://schemas.openxmlformats.org/officeDocument/2006/relationships" xmlns:p="http://schemas.openxmlformats.org/presentationml/2006/main">
   <p:cSld>
     <p:spTree>
@@ -46039,7 +44592,7 @@
 </p:sld>
 </file>
 
-<file path=ppt/slides/slide16.xml><?xml version="1.0" encoding="utf-8"?>
+<file path=ppt/slides/slide12.xml><?xml version="1.0" encoding="utf-8"?>
 <p:sld xmlns:a="http://schemas.openxmlformats.org/drawingml/2006/main" xmlns:r="http://schemas.openxmlformats.org/officeDocument/2006/relationships" xmlns:p="http://schemas.openxmlformats.org/presentationml/2006/main">
   <p:cSld>
     <p:spTree>
@@ -46371,7 +44924,7 @@
 </p:sld>
 </file>
 
-<file path=ppt/slides/slide17.xml><?xml version="1.0" encoding="utf-8"?>
+<file path=ppt/slides/slide13.xml><?xml version="1.0" encoding="utf-8"?>
 <p:sld xmlns:a="http://schemas.openxmlformats.org/drawingml/2006/main" xmlns:r="http://schemas.openxmlformats.org/officeDocument/2006/relationships" xmlns:p="http://schemas.openxmlformats.org/presentationml/2006/main">
   <p:cSld>
     <p:spTree>
@@ -47127,244 +45680,7 @@
 </p:sld>
 </file>
 
-<file path=ppt/slides/slide18.xml><?xml version="1.0" encoding="utf-8"?>
-<p:sld xmlns:a="http://schemas.openxmlformats.org/drawingml/2006/main" xmlns:r="http://schemas.openxmlformats.org/officeDocument/2006/relationships" xmlns:p="http://schemas.openxmlformats.org/presentationml/2006/main">
-  <p:cSld>
-    <p:spTree>
-      <p:nvGrpSpPr>
-        <p:cNvPr id="318" name="Shape 318"/>
-        <p:cNvGrpSpPr/>
-        <p:nvPr/>
-      </p:nvGrpSpPr>
-      <p:grpSpPr>
-        <a:xfrm>
-          <a:off x="0" y="0"/>
-          <a:ext cx="0" cy="0"/>
-          <a:chOff x="0" y="0"/>
-          <a:chExt cx="0" cy="0"/>
-        </a:xfrm>
-      </p:grpSpPr>
-      <p:sp>
-        <p:nvSpPr>
-          <p:cNvPr id="332" name="Google Shape;332;p28"/>
-          <p:cNvSpPr txBox="1"/>
-          <p:nvPr>
-            <p:ph type="title"/>
-          </p:nvPr>
-        </p:nvSpPr>
-        <p:spPr>
-          <a:xfrm>
-            <a:off x="1470929" y="2095027"/>
-            <a:ext cx="9941071" cy="884656"/>
-          </a:xfrm>
-          <a:prstGeom prst="rect">
-            <a:avLst/>
-          </a:prstGeom>
-          <a:noFill/>
-          <a:ln>
-            <a:noFill/>
-          </a:ln>
-        </p:spPr>
-        <p:txBody>
-          <a:bodyPr/>
-          <a:lstStyle/>
-          <a:p>
-            <a:pPr lvl="0" indent="0" marL="0">
-              <a:buNone/>
-            </a:pPr>
-            <a:r>
-              <a:rPr/>
-              <a:t>Đóng góp kỹ thuật</a:t>
-            </a:r>
-          </a:p>
-        </p:txBody>
-      </p:sp>
-      <p:sp>
-        <p:nvSpPr>
-          <p:cNvPr id="347" name="Google Shape;347;p28"/>
-          <p:cNvSpPr txBox="1"/>
-          <p:nvPr>
-            <p:ph idx="12" type="sldNum"/>
-          </p:nvPr>
-        </p:nvSpPr>
-        <p:spPr>
-          <a:xfrm>
-            <a:off x="65862" y="6542216"/>
-            <a:ext cx="292608" cy="315784"/>
-          </a:xfrm>
-          <a:prstGeom prst="rect">
-            <a:avLst/>
-          </a:prstGeom>
-          <a:noFill/>
-          <a:ln>
-            <a:noFill/>
-          </a:ln>
-        </p:spPr>
-        <p:txBody>
-          <a:bodyPr anchor="ctr" anchorCtr="0" bIns="45700" lIns="91425" rIns="91425" spcFirstLastPara="1" tIns="45700" wrap="square">
-            <a:noAutofit/>
-          </a:bodyPr>
-          <a:lstStyle>
-            <a:lvl1pPr algn="ctr" indent="0" lvl="0" marL="0">
-              <a:spcBef>
-                <a:spcPts val="0"/>
-              </a:spcBef>
-              <a:buNone/>
-              <a:defRPr sz="700">
-                <a:solidFill>
-                  <a:schemeClr val="dk1"/>
-                </a:solidFill>
-                <a:latin typeface="Arial"/>
-                <a:ea typeface="Arial"/>
-                <a:cs typeface="Arial"/>
-                <a:sym typeface="Arial"/>
-              </a:defRPr>
-            </a:lvl1pPr>
-            <a:lvl2pPr algn="ctr" indent="0" lvl="1" marL="0">
-              <a:spcBef>
-                <a:spcPts val="0"/>
-              </a:spcBef>
-              <a:buNone/>
-              <a:defRPr sz="700">
-                <a:solidFill>
-                  <a:schemeClr val="dk1"/>
-                </a:solidFill>
-                <a:latin typeface="Arial"/>
-                <a:ea typeface="Arial"/>
-                <a:cs typeface="Arial"/>
-                <a:sym typeface="Arial"/>
-              </a:defRPr>
-            </a:lvl2pPr>
-            <a:lvl3pPr algn="ctr" indent="0" lvl="2" marL="0">
-              <a:spcBef>
-                <a:spcPts val="0"/>
-              </a:spcBef>
-              <a:buNone/>
-              <a:defRPr sz="700">
-                <a:solidFill>
-                  <a:schemeClr val="dk1"/>
-                </a:solidFill>
-                <a:latin typeface="Arial"/>
-                <a:ea typeface="Arial"/>
-                <a:cs typeface="Arial"/>
-                <a:sym typeface="Arial"/>
-              </a:defRPr>
-            </a:lvl3pPr>
-            <a:lvl4pPr algn="ctr" indent="0" lvl="3" marL="0">
-              <a:spcBef>
-                <a:spcPts val="0"/>
-              </a:spcBef>
-              <a:buNone/>
-              <a:defRPr sz="700">
-                <a:solidFill>
-                  <a:schemeClr val="dk1"/>
-                </a:solidFill>
-                <a:latin typeface="Arial"/>
-                <a:ea typeface="Arial"/>
-                <a:cs typeface="Arial"/>
-                <a:sym typeface="Arial"/>
-              </a:defRPr>
-            </a:lvl4pPr>
-            <a:lvl5pPr algn="ctr" indent="0" lvl="4" marL="0">
-              <a:spcBef>
-                <a:spcPts val="0"/>
-              </a:spcBef>
-              <a:buNone/>
-              <a:defRPr sz="700">
-                <a:solidFill>
-                  <a:schemeClr val="dk1"/>
-                </a:solidFill>
-                <a:latin typeface="Arial"/>
-                <a:ea typeface="Arial"/>
-                <a:cs typeface="Arial"/>
-                <a:sym typeface="Arial"/>
-              </a:defRPr>
-            </a:lvl5pPr>
-            <a:lvl6pPr algn="ctr" indent="0" lvl="5" marL="0">
-              <a:spcBef>
-                <a:spcPts val="0"/>
-              </a:spcBef>
-              <a:buNone/>
-              <a:defRPr sz="700">
-                <a:solidFill>
-                  <a:schemeClr val="dk1"/>
-                </a:solidFill>
-                <a:latin typeface="Arial"/>
-                <a:ea typeface="Arial"/>
-                <a:cs typeface="Arial"/>
-                <a:sym typeface="Arial"/>
-              </a:defRPr>
-            </a:lvl6pPr>
-            <a:lvl7pPr algn="ctr" indent="0" lvl="6" marL="0">
-              <a:spcBef>
-                <a:spcPts val="0"/>
-              </a:spcBef>
-              <a:buNone/>
-              <a:defRPr sz="700">
-                <a:solidFill>
-                  <a:schemeClr val="dk1"/>
-                </a:solidFill>
-                <a:latin typeface="Arial"/>
-                <a:ea typeface="Arial"/>
-                <a:cs typeface="Arial"/>
-                <a:sym typeface="Arial"/>
-              </a:defRPr>
-            </a:lvl7pPr>
-            <a:lvl8pPr algn="ctr" indent="0" lvl="7" marL="0">
-              <a:spcBef>
-                <a:spcPts val="0"/>
-              </a:spcBef>
-              <a:buNone/>
-              <a:defRPr sz="700">
-                <a:solidFill>
-                  <a:schemeClr val="dk1"/>
-                </a:solidFill>
-                <a:latin typeface="Arial"/>
-                <a:ea typeface="Arial"/>
-                <a:cs typeface="Arial"/>
-                <a:sym typeface="Arial"/>
-              </a:defRPr>
-            </a:lvl8pPr>
-            <a:lvl9pPr algn="ctr" indent="0" lvl="8" marL="0">
-              <a:spcBef>
-                <a:spcPts val="0"/>
-              </a:spcBef>
-              <a:buNone/>
-              <a:defRPr sz="700">
-                <a:solidFill>
-                  <a:schemeClr val="dk1"/>
-                </a:solidFill>
-                <a:latin typeface="Arial"/>
-                <a:ea typeface="Arial"/>
-                <a:cs typeface="Arial"/>
-                <a:sym typeface="Arial"/>
-              </a:defRPr>
-            </a:lvl9pPr>
-          </a:lstStyle>
-          <a:p>
-            <a:pPr algn="ctr" indent="0" lvl="0" marL="0" rtl="0">
-              <a:spcBef>
-                <a:spcPts val="0"/>
-              </a:spcBef>
-              <a:spcAft>
-                <a:spcPts val="0"/>
-              </a:spcAft>
-              <a:buNone/>
-            </a:pPr>
-            <a:fld id="{00000000-1234-1234-1234-123412341234}" type="slidenum">
-              <a:rPr lang="en-US"/>
-              <a:t>‹#›</a:t>
-            </a:fld>
-            <a:endParaRPr/>
-          </a:p>
-        </p:txBody>
-      </p:sp>
-    </p:spTree>
-  </p:cSld>
-</p:sld>
-</file>
-
-<file path=ppt/slides/slide19.xml><?xml version="1.0" encoding="utf-8"?>
+<file path=ppt/slides/slide14.xml><?xml version="1.0" encoding="utf-8"?>
 <p:sld xmlns:a="http://schemas.openxmlformats.org/drawingml/2006/main" xmlns:r="http://schemas.openxmlformats.org/officeDocument/2006/relationships" xmlns:p="http://schemas.openxmlformats.org/presentationml/2006/main">
   <p:cSld>
     <p:spTree>
@@ -47678,244 +45994,7 @@
 </p:sld>
 </file>
 
-<file path=ppt/slides/slide2.xml><?xml version="1.0" encoding="utf-8"?>
-<p:sld xmlns:a="http://schemas.openxmlformats.org/drawingml/2006/main" xmlns:r="http://schemas.openxmlformats.org/officeDocument/2006/relationships" xmlns:p="http://schemas.openxmlformats.org/presentationml/2006/main">
-  <p:cSld>
-    <p:spTree>
-      <p:nvGrpSpPr>
-        <p:cNvPr id="318" name="Shape 318"/>
-        <p:cNvGrpSpPr/>
-        <p:nvPr/>
-      </p:nvGrpSpPr>
-      <p:grpSpPr>
-        <a:xfrm>
-          <a:off x="0" y="0"/>
-          <a:ext cx="0" cy="0"/>
-          <a:chOff x="0" y="0"/>
-          <a:chExt cx="0" cy="0"/>
-        </a:xfrm>
-      </p:grpSpPr>
-      <p:sp>
-        <p:nvSpPr>
-          <p:cNvPr id="332" name="Google Shape;332;p28"/>
-          <p:cNvSpPr txBox="1"/>
-          <p:nvPr>
-            <p:ph type="title"/>
-          </p:nvPr>
-        </p:nvSpPr>
-        <p:spPr>
-          <a:xfrm>
-            <a:off x="1470929" y="2095027"/>
-            <a:ext cx="9941071" cy="884656"/>
-          </a:xfrm>
-          <a:prstGeom prst="rect">
-            <a:avLst/>
-          </a:prstGeom>
-          <a:noFill/>
-          <a:ln>
-            <a:noFill/>
-          </a:ln>
-        </p:spPr>
-        <p:txBody>
-          <a:bodyPr/>
-          <a:lstStyle/>
-          <a:p>
-            <a:pPr lvl="0" indent="0" marL="0">
-              <a:buNone/>
-            </a:pPr>
-            <a:r>
-              <a:rPr/>
-              <a:t>Mở đầu</a:t>
-            </a:r>
-          </a:p>
-        </p:txBody>
-      </p:sp>
-      <p:sp>
-        <p:nvSpPr>
-          <p:cNvPr id="347" name="Google Shape;347;p28"/>
-          <p:cNvSpPr txBox="1"/>
-          <p:nvPr>
-            <p:ph idx="12" type="sldNum"/>
-          </p:nvPr>
-        </p:nvSpPr>
-        <p:spPr>
-          <a:xfrm>
-            <a:off x="65862" y="6542216"/>
-            <a:ext cx="292608" cy="315784"/>
-          </a:xfrm>
-          <a:prstGeom prst="rect">
-            <a:avLst/>
-          </a:prstGeom>
-          <a:noFill/>
-          <a:ln>
-            <a:noFill/>
-          </a:ln>
-        </p:spPr>
-        <p:txBody>
-          <a:bodyPr anchor="ctr" anchorCtr="0" bIns="45700" lIns="91425" rIns="91425" spcFirstLastPara="1" tIns="45700" wrap="square">
-            <a:noAutofit/>
-          </a:bodyPr>
-          <a:lstStyle>
-            <a:lvl1pPr algn="ctr" indent="0" lvl="0" marL="0">
-              <a:spcBef>
-                <a:spcPts val="0"/>
-              </a:spcBef>
-              <a:buNone/>
-              <a:defRPr sz="700">
-                <a:solidFill>
-                  <a:schemeClr val="dk1"/>
-                </a:solidFill>
-                <a:latin typeface="Arial"/>
-                <a:ea typeface="Arial"/>
-                <a:cs typeface="Arial"/>
-                <a:sym typeface="Arial"/>
-              </a:defRPr>
-            </a:lvl1pPr>
-            <a:lvl2pPr algn="ctr" indent="0" lvl="1" marL="0">
-              <a:spcBef>
-                <a:spcPts val="0"/>
-              </a:spcBef>
-              <a:buNone/>
-              <a:defRPr sz="700">
-                <a:solidFill>
-                  <a:schemeClr val="dk1"/>
-                </a:solidFill>
-                <a:latin typeface="Arial"/>
-                <a:ea typeface="Arial"/>
-                <a:cs typeface="Arial"/>
-                <a:sym typeface="Arial"/>
-              </a:defRPr>
-            </a:lvl2pPr>
-            <a:lvl3pPr algn="ctr" indent="0" lvl="2" marL="0">
-              <a:spcBef>
-                <a:spcPts val="0"/>
-              </a:spcBef>
-              <a:buNone/>
-              <a:defRPr sz="700">
-                <a:solidFill>
-                  <a:schemeClr val="dk1"/>
-                </a:solidFill>
-                <a:latin typeface="Arial"/>
-                <a:ea typeface="Arial"/>
-                <a:cs typeface="Arial"/>
-                <a:sym typeface="Arial"/>
-              </a:defRPr>
-            </a:lvl3pPr>
-            <a:lvl4pPr algn="ctr" indent="0" lvl="3" marL="0">
-              <a:spcBef>
-                <a:spcPts val="0"/>
-              </a:spcBef>
-              <a:buNone/>
-              <a:defRPr sz="700">
-                <a:solidFill>
-                  <a:schemeClr val="dk1"/>
-                </a:solidFill>
-                <a:latin typeface="Arial"/>
-                <a:ea typeface="Arial"/>
-                <a:cs typeface="Arial"/>
-                <a:sym typeface="Arial"/>
-              </a:defRPr>
-            </a:lvl4pPr>
-            <a:lvl5pPr algn="ctr" indent="0" lvl="4" marL="0">
-              <a:spcBef>
-                <a:spcPts val="0"/>
-              </a:spcBef>
-              <a:buNone/>
-              <a:defRPr sz="700">
-                <a:solidFill>
-                  <a:schemeClr val="dk1"/>
-                </a:solidFill>
-                <a:latin typeface="Arial"/>
-                <a:ea typeface="Arial"/>
-                <a:cs typeface="Arial"/>
-                <a:sym typeface="Arial"/>
-              </a:defRPr>
-            </a:lvl5pPr>
-            <a:lvl6pPr algn="ctr" indent="0" lvl="5" marL="0">
-              <a:spcBef>
-                <a:spcPts val="0"/>
-              </a:spcBef>
-              <a:buNone/>
-              <a:defRPr sz="700">
-                <a:solidFill>
-                  <a:schemeClr val="dk1"/>
-                </a:solidFill>
-                <a:latin typeface="Arial"/>
-                <a:ea typeface="Arial"/>
-                <a:cs typeface="Arial"/>
-                <a:sym typeface="Arial"/>
-              </a:defRPr>
-            </a:lvl6pPr>
-            <a:lvl7pPr algn="ctr" indent="0" lvl="6" marL="0">
-              <a:spcBef>
-                <a:spcPts val="0"/>
-              </a:spcBef>
-              <a:buNone/>
-              <a:defRPr sz="700">
-                <a:solidFill>
-                  <a:schemeClr val="dk1"/>
-                </a:solidFill>
-                <a:latin typeface="Arial"/>
-                <a:ea typeface="Arial"/>
-                <a:cs typeface="Arial"/>
-                <a:sym typeface="Arial"/>
-              </a:defRPr>
-            </a:lvl7pPr>
-            <a:lvl8pPr algn="ctr" indent="0" lvl="7" marL="0">
-              <a:spcBef>
-                <a:spcPts val="0"/>
-              </a:spcBef>
-              <a:buNone/>
-              <a:defRPr sz="700">
-                <a:solidFill>
-                  <a:schemeClr val="dk1"/>
-                </a:solidFill>
-                <a:latin typeface="Arial"/>
-                <a:ea typeface="Arial"/>
-                <a:cs typeface="Arial"/>
-                <a:sym typeface="Arial"/>
-              </a:defRPr>
-            </a:lvl8pPr>
-            <a:lvl9pPr algn="ctr" indent="0" lvl="8" marL="0">
-              <a:spcBef>
-                <a:spcPts val="0"/>
-              </a:spcBef>
-              <a:buNone/>
-              <a:defRPr sz="700">
-                <a:solidFill>
-                  <a:schemeClr val="dk1"/>
-                </a:solidFill>
-                <a:latin typeface="Arial"/>
-                <a:ea typeface="Arial"/>
-                <a:cs typeface="Arial"/>
-                <a:sym typeface="Arial"/>
-              </a:defRPr>
-            </a:lvl9pPr>
-          </a:lstStyle>
-          <a:p>
-            <a:pPr algn="ctr" indent="0" lvl="0" marL="0" rtl="0">
-              <a:spcBef>
-                <a:spcPts val="0"/>
-              </a:spcBef>
-              <a:spcAft>
-                <a:spcPts val="0"/>
-              </a:spcAft>
-              <a:buNone/>
-            </a:pPr>
-            <a:fld id="{00000000-1234-1234-1234-123412341234}" type="slidenum">
-              <a:rPr lang="en-US"/>
-              <a:t>‹#›</a:t>
-            </a:fld>
-            <a:endParaRPr/>
-          </a:p>
-        </p:txBody>
-      </p:sp>
-    </p:spTree>
-  </p:cSld>
-</p:sld>
-</file>
-
-<file path=ppt/slides/slide20.xml><?xml version="1.0" encoding="utf-8"?>
+<file path=ppt/slides/slide15.xml><?xml version="1.0" encoding="utf-8"?>
 <p:sld xmlns:a="http://schemas.openxmlformats.org/drawingml/2006/main" xmlns:r="http://schemas.openxmlformats.org/officeDocument/2006/relationships" xmlns:p="http://schemas.openxmlformats.org/presentationml/2006/main">
   <p:cSld>
     <p:spTree>
@@ -48514,7 +46593,7 @@
 </p:sld>
 </file>
 
-<file path=ppt/slides/slide21.xml><?xml version="1.0" encoding="utf-8"?>
+<file path=ppt/slides/slide16.xml><?xml version="1.0" encoding="utf-8"?>
 <p:sld xmlns:a="http://schemas.openxmlformats.org/drawingml/2006/main" xmlns:r="http://schemas.openxmlformats.org/officeDocument/2006/relationships" xmlns:p="http://schemas.openxmlformats.org/presentationml/2006/main">
   <p:cSld>
     <p:spTree>
@@ -49128,7 +47207,7 @@
 </p:sld>
 </file>
 
-<file path=ppt/slides/slide22.xml><?xml version="1.0" encoding="utf-8"?>
+<file path=ppt/slides/slide17.xml><?xml version="1.0" encoding="utf-8"?>
 <p:sld xmlns:a="http://schemas.openxmlformats.org/drawingml/2006/main" xmlns:r="http://schemas.openxmlformats.org/officeDocument/2006/relationships" xmlns:p="http://schemas.openxmlformats.org/presentationml/2006/main">
   <p:cSld>
     <p:spTree>
@@ -49418,7 +47497,7 @@
 </p:sld>
 </file>
 
-<file path=ppt/slides/slide23.xml><?xml version="1.0" encoding="utf-8"?>
+<file path=ppt/slides/slide18.xml><?xml version="1.0" encoding="utf-8"?>
 <p:sld xmlns:a="http://schemas.openxmlformats.org/drawingml/2006/main" xmlns:r="http://schemas.openxmlformats.org/officeDocument/2006/relationships" xmlns:p="http://schemas.openxmlformats.org/presentationml/2006/main">
   <p:cSld>
     <p:spTree>
@@ -49913,7 +47992,7 @@
 </p:sld>
 </file>
 
-<file path=ppt/slides/slide24.xml><?xml version="1.0" encoding="utf-8"?>
+<file path=ppt/slides/slide19.xml><?xml version="1.0" encoding="utf-8"?>
 <p:sld xmlns:a="http://schemas.openxmlformats.org/drawingml/2006/main" xmlns:r="http://schemas.openxmlformats.org/officeDocument/2006/relationships" xmlns:p="http://schemas.openxmlformats.org/presentationml/2006/main">
   <p:cSld>
     <p:spTree>
@@ -50320,12 +48399,12 @@
 </p:sld>
 </file>
 
-<file path=ppt/slides/slide25.xml><?xml version="1.0" encoding="utf-8"?>
+<file path=ppt/slides/slide2.xml><?xml version="1.0" encoding="utf-8"?>
 <p:sld xmlns:a="http://schemas.openxmlformats.org/drawingml/2006/main" xmlns:r="http://schemas.openxmlformats.org/officeDocument/2006/relationships" xmlns:p="http://schemas.openxmlformats.org/presentationml/2006/main">
   <p:cSld>
     <p:spTree>
       <p:nvGrpSpPr>
-        <p:cNvPr id="318" name="Shape 318"/>
+        <p:cNvPr id="134" name="Shape 134"/>
         <p:cNvGrpSpPr/>
         <p:nvPr/>
       </p:nvGrpSpPr>
@@ -50339,7 +48418,7 @@
       </p:grpSpPr>
       <p:sp>
         <p:nvSpPr>
-          <p:cNvPr id="332" name="Google Shape;332;p28"/>
+          <p:cNvPr id="142" name="Google Shape;142;p23"/>
           <p:cNvSpPr txBox="1"/>
           <p:nvPr>
             <p:ph type="title"/>
@@ -50347,8 +48426,8 @@
         </p:nvSpPr>
         <p:spPr>
           <a:xfrm>
-            <a:off x="1470929" y="2095027"/>
-            <a:ext cx="9941071" cy="884656"/>
+            <a:off x="774145" y="223964"/>
+            <a:ext cx="10579655" cy="785896"/>
           </a:xfrm>
           <a:prstGeom prst="rect">
             <a:avLst/>
@@ -50367,14 +48446,73 @@
             </a:pPr>
             <a:r>
               <a:rPr/>
-              <a:t>Kết quả và hệ thống</a:t>
+              <a:t>NỘI DUNG</a:t>
             </a:r>
           </a:p>
         </p:txBody>
       </p:sp>
       <p:sp>
         <p:nvSpPr>
-          <p:cNvPr id="347" name="Google Shape;347;p28"/>
+          <p:cNvPr id="143" name="Google Shape;143;p23"/>
+          <p:cNvSpPr txBox="1"/>
+          <p:nvPr>
+            <p:ph idx="1"/>
+          </p:nvPr>
+        </p:nvSpPr>
+        <p:spPr/>
+        <p:txBody>
+          <a:bodyPr/>
+          <a:lstStyle/>
+          <a:p>
+            <a:pPr lvl="0" indent="0" marL="347663">
+              <a:buAutoNum type="arabicPeriod"/>
+            </a:pPr>
+            <a:r>
+              <a:rPr b="1"/>
+              <a:t>Tổng quan đề tài</a:t>
+            </a:r>
+          </a:p>
+          <a:p>
+            <a:pPr lvl="0" indent="0" marL="347663">
+              <a:buAutoNum type="arabicPeriod"/>
+            </a:pPr>
+            <a:r>
+              <a:rPr b="1"/>
+              <a:t>Cơ sở lý thuyết</a:t>
+            </a:r>
+          </a:p>
+          <a:p>
+            <a:pPr lvl="0" indent="0" marL="347663">
+              <a:buAutoNum type="arabicPeriod"/>
+            </a:pPr>
+            <a:r>
+              <a:rPr b="1"/>
+              <a:t>Phân tích và thiết kế hệ thống</a:t>
+            </a:r>
+          </a:p>
+          <a:p>
+            <a:pPr lvl="0" indent="0" marL="347663">
+              <a:buAutoNum type="arabicPeriod"/>
+            </a:pPr>
+            <a:r>
+              <a:rPr b="1"/>
+              <a:t>Kết quả thực nghiệm</a:t>
+            </a:r>
+          </a:p>
+          <a:p>
+            <a:pPr lvl="0" indent="0" marL="347663">
+              <a:buAutoNum type="arabicPeriod"/>
+            </a:pPr>
+            <a:r>
+              <a:rPr b="1"/>
+              <a:t>Kết luận và hướng phát triển</a:t>
+            </a:r>
+          </a:p>
+        </p:txBody>
+      </p:sp>
+      <p:sp>
+        <p:nvSpPr>
+          <p:cNvPr id="155" name="Google Shape;155;p23"/>
           <p:cNvSpPr txBox="1"/>
           <p:nvPr>
             <p:ph idx="12" type="sldNum"/>
@@ -50382,8 +48520,8 @@
         </p:nvSpPr>
         <p:spPr>
           <a:xfrm>
-            <a:off x="65862" y="6542216"/>
-            <a:ext cx="292608" cy="315784"/>
+            <a:off x="58380" y="6508358"/>
+            <a:ext cx="349642" cy="349642"/>
           </a:xfrm>
           <a:prstGeom prst="rect">
             <a:avLst/>
@@ -50557,7 +48695,7 @@
 </p:sld>
 </file>
 
-<file path=ppt/slides/slide26.xml><?xml version="1.0" encoding="utf-8"?>
+<file path=ppt/slides/slide20.xml><?xml version="1.0" encoding="utf-8"?>
 <p:sld xmlns:a="http://schemas.openxmlformats.org/drawingml/2006/main" xmlns:r="http://schemas.openxmlformats.org/officeDocument/2006/relationships" xmlns:p="http://schemas.openxmlformats.org/presentationml/2006/main">
   <p:cSld>
     <p:spTree>
@@ -50855,7 +48993,7 @@
 </p:sld>
 </file>
 
-<file path=ppt/slides/slide27.xml><?xml version="1.0" encoding="utf-8"?>
+<file path=ppt/slides/slide21.xml><?xml version="1.0" encoding="utf-8"?>
 <p:sld xmlns:a="http://schemas.openxmlformats.org/drawingml/2006/main" xmlns:r="http://schemas.openxmlformats.org/officeDocument/2006/relationships" xmlns:p="http://schemas.openxmlformats.org/presentationml/2006/main">
   <p:cSld>
     <p:spTree>
@@ -51277,7 +49415,7 @@
 </p:sld>
 </file>
 
-<file path=ppt/slides/slide28.xml><?xml version="1.0" encoding="utf-8"?>
+<file path=ppt/slides/slide22.xml><?xml version="1.0" encoding="utf-8"?>
 <p:sld xmlns:a="http://schemas.openxmlformats.org/drawingml/2006/main" xmlns:r="http://schemas.openxmlformats.org/officeDocument/2006/relationships" xmlns:p="http://schemas.openxmlformats.org/presentationml/2006/main">
   <p:cSld>
     <p:spTree>
@@ -51597,7 +49735,7 @@
 </p:sld>
 </file>
 
-<file path=ppt/slides/slide29.xml><?xml version="1.0" encoding="utf-8"?>
+<file path=ppt/slides/slide23.xml><?xml version="1.0" encoding="utf-8"?>
 <p:sld xmlns:a="http://schemas.openxmlformats.org/drawingml/2006/main" xmlns:r="http://schemas.openxmlformats.org/officeDocument/2006/relationships" xmlns:p="http://schemas.openxmlformats.org/presentationml/2006/main">
   <p:cSld>
     <p:spTree>
@@ -52102,335 +50240,7 @@
 </p:sld>
 </file>
 
-<file path=ppt/slides/slide3.xml><?xml version="1.0" encoding="utf-8"?>
-<p:sld xmlns:a="http://schemas.openxmlformats.org/drawingml/2006/main" xmlns:r="http://schemas.openxmlformats.org/officeDocument/2006/relationships" xmlns:p="http://schemas.openxmlformats.org/presentationml/2006/main">
-  <p:cSld>
-    <p:spTree>
-      <p:nvGrpSpPr>
-        <p:cNvPr id="428" name="Shape 428"/>
-        <p:cNvGrpSpPr/>
-        <p:nvPr/>
-      </p:nvGrpSpPr>
-      <p:grpSpPr>
-        <a:xfrm>
-          <a:off x="0" y="0"/>
-          <a:ext cx="0" cy="0"/>
-          <a:chOff x="0" y="0"/>
-          <a:chExt cx="0" cy="0"/>
-        </a:xfrm>
-      </p:grpSpPr>
-      <p:sp>
-        <p:nvSpPr>
-          <p:cNvPr id="436" name="Google Shape;436;p31"/>
-          <p:cNvSpPr txBox="1"/>
-          <p:nvPr>
-            <p:ph type="title"/>
-          </p:nvPr>
-        </p:nvSpPr>
-        <p:spPr>
-          <a:xfrm>
-            <a:off x="774146" y="202009"/>
-            <a:ext cx="3932227" cy="1698043"/>
-          </a:xfrm>
-          <a:prstGeom prst="rect">
-            <a:avLst/>
-          </a:prstGeom>
-          <a:noFill/>
-          <a:ln>
-            <a:noFill/>
-          </a:ln>
-        </p:spPr>
-        <p:txBody>
-          <a:bodyPr/>
-          <a:lstStyle/>
-          <a:p>
-            <a:pPr lvl="0" indent="0" marL="0">
-              <a:buNone/>
-            </a:pPr>
-            <a:r>
-              <a:rPr/>
-              <a:t>Vì sao đề tài này</a:t>
-            </a:r>
-          </a:p>
-        </p:txBody>
-      </p:sp>
-      <p:sp>
-        <p:nvSpPr>
-          <p:cNvPr id="437" name="Google Shape;437;p31"/>
-          <p:cNvSpPr txBox="1"/>
-          <p:nvPr>
-            <p:ph idx="2" sz="half" type="body"/>
-          </p:nvPr>
-        </p:nvSpPr>
-        <p:spPr/>
-        <p:txBody>
-          <a:bodyPr/>
-          <a:lstStyle/>
-          <a:p>
-            <a:pPr lvl="0" indent="0" marL="0">
-              <a:buNone/>
-            </a:pPr>
-            <a:r>
-              <a:rPr b="1"/>
-              <a:t>~77 triệu xe máy</a:t>
-            </a:r>
-            <a:r>
-              <a:rPr/>
-              <a:t> — </a:t>
-            </a:r>
-            <a:r>
-              <a:rPr b="1"/>
-              <a:t>85–90%</a:t>
-            </a:r>
-            <a:r>
-              <a:rPr/>
-              <a:t> lưu lượng đường bộ Việt Nam</a:t>
-            </a:r>
-          </a:p>
-          <a:p>
-            <a:pPr lvl="0" indent="0" marL="0">
-              <a:buNone/>
-            </a:pPr>
-            <a:r>
-              <a:rPr/>
-              <a:t>Cùng hệ thống, cùng phép đo: </a:t>
-            </a:r>
-            <a:r>
-              <a:rPr b="1"/>
-              <a:t>chênh 48,6 điểm</a:t>
-            </a:r>
-            <a:r>
-              <a:rPr/>
-              <a:t>, chỉ khác bố cục</a:t>
-            </a:r>
-          </a:p>
-          <a:p>
-            <a:pPr lvl="0" indent="0" marL="0">
-              <a:buNone/>
-            </a:pPr>
-            <a:r>
-              <a:rPr i="1"/>
-              <a:t>Số liệu Brazil, không phải Việt Nam</a:t>
-            </a:r>
-          </a:p>
-        </p:txBody>
-      </p:sp>
-      <p:pic>
-        <p:nvPicPr>
-          <p:cNvPr descr="figures/fig-gap.png" id="0" name="Picture 1"/>
-          <p:cNvPicPr>
-            <a:picLocks noGrp="1" noChangeAspect="1"/>
-          </p:cNvPicPr>
-          <p:nvPr/>
-        </p:nvPicPr>
-        <p:blipFill>
-          <a:blip r:embed="rId2"/>
-          <a:stretch>
-            <a:fillRect/>
-          </a:stretch>
-        </p:blipFill>
-        <p:spPr bwMode="auto">
-          <a:xfrm>
-            <a:off x="5156200" y="787400"/>
-            <a:ext cx="6235700" cy="4762500"/>
-          </a:xfrm>
-          <a:prstGeom prst="rect">
-            <a:avLst/>
-          </a:prstGeom>
-          <a:noFill/>
-          <a:ln w="9525">
-            <a:noFill/>
-            <a:headEnd/>
-            <a:tailEnd/>
-          </a:ln>
-        </p:spPr>
-      </p:pic>
-      <p:sp>
-        <p:nvSpPr>
-          <p:cNvPr id="449" name="Google Shape;449;p31"/>
-          <p:cNvSpPr txBox="1"/>
-          <p:nvPr>
-            <p:ph idx="12" type="sldNum"/>
-          </p:nvPr>
-        </p:nvSpPr>
-        <p:spPr>
-          <a:xfrm>
-            <a:off x="58380" y="6508358"/>
-            <a:ext cx="349642" cy="349642"/>
-          </a:xfrm>
-          <a:prstGeom prst="rect">
-            <a:avLst/>
-          </a:prstGeom>
-          <a:noFill/>
-          <a:ln>
-            <a:noFill/>
-          </a:ln>
-        </p:spPr>
-        <p:txBody>
-          <a:bodyPr anchor="ctr" anchorCtr="0" bIns="45700" lIns="91425" rIns="91425" spcFirstLastPara="1" tIns="45700" wrap="square">
-            <a:noAutofit/>
-          </a:bodyPr>
-          <a:lstStyle>
-            <a:lvl1pPr algn="ctr" indent="0" lvl="0" marL="0">
-              <a:spcBef>
-                <a:spcPts val="0"/>
-              </a:spcBef>
-              <a:buNone/>
-              <a:defRPr sz="700">
-                <a:solidFill>
-                  <a:schemeClr val="dk1"/>
-                </a:solidFill>
-                <a:latin typeface="Arial"/>
-                <a:ea typeface="Arial"/>
-                <a:cs typeface="Arial"/>
-                <a:sym typeface="Arial"/>
-              </a:defRPr>
-            </a:lvl1pPr>
-            <a:lvl2pPr algn="ctr" indent="0" lvl="1" marL="0">
-              <a:spcBef>
-                <a:spcPts val="0"/>
-              </a:spcBef>
-              <a:buNone/>
-              <a:defRPr sz="700">
-                <a:solidFill>
-                  <a:schemeClr val="dk1"/>
-                </a:solidFill>
-                <a:latin typeface="Arial"/>
-                <a:ea typeface="Arial"/>
-                <a:cs typeface="Arial"/>
-                <a:sym typeface="Arial"/>
-              </a:defRPr>
-            </a:lvl2pPr>
-            <a:lvl3pPr algn="ctr" indent="0" lvl="2" marL="0">
-              <a:spcBef>
-                <a:spcPts val="0"/>
-              </a:spcBef>
-              <a:buNone/>
-              <a:defRPr sz="700">
-                <a:solidFill>
-                  <a:schemeClr val="dk1"/>
-                </a:solidFill>
-                <a:latin typeface="Arial"/>
-                <a:ea typeface="Arial"/>
-                <a:cs typeface="Arial"/>
-                <a:sym typeface="Arial"/>
-              </a:defRPr>
-            </a:lvl3pPr>
-            <a:lvl4pPr algn="ctr" indent="0" lvl="3" marL="0">
-              <a:spcBef>
-                <a:spcPts val="0"/>
-              </a:spcBef>
-              <a:buNone/>
-              <a:defRPr sz="700">
-                <a:solidFill>
-                  <a:schemeClr val="dk1"/>
-                </a:solidFill>
-                <a:latin typeface="Arial"/>
-                <a:ea typeface="Arial"/>
-                <a:cs typeface="Arial"/>
-                <a:sym typeface="Arial"/>
-              </a:defRPr>
-            </a:lvl4pPr>
-            <a:lvl5pPr algn="ctr" indent="0" lvl="4" marL="0">
-              <a:spcBef>
-                <a:spcPts val="0"/>
-              </a:spcBef>
-              <a:buNone/>
-              <a:defRPr sz="700">
-                <a:solidFill>
-                  <a:schemeClr val="dk1"/>
-                </a:solidFill>
-                <a:latin typeface="Arial"/>
-                <a:ea typeface="Arial"/>
-                <a:cs typeface="Arial"/>
-                <a:sym typeface="Arial"/>
-              </a:defRPr>
-            </a:lvl5pPr>
-            <a:lvl6pPr algn="ctr" indent="0" lvl="5" marL="0">
-              <a:spcBef>
-                <a:spcPts val="0"/>
-              </a:spcBef>
-              <a:buNone/>
-              <a:defRPr sz="700">
-                <a:solidFill>
-                  <a:schemeClr val="dk1"/>
-                </a:solidFill>
-                <a:latin typeface="Arial"/>
-                <a:ea typeface="Arial"/>
-                <a:cs typeface="Arial"/>
-                <a:sym typeface="Arial"/>
-              </a:defRPr>
-            </a:lvl6pPr>
-            <a:lvl7pPr algn="ctr" indent="0" lvl="6" marL="0">
-              <a:spcBef>
-                <a:spcPts val="0"/>
-              </a:spcBef>
-              <a:buNone/>
-              <a:defRPr sz="700">
-                <a:solidFill>
-                  <a:schemeClr val="dk1"/>
-                </a:solidFill>
-                <a:latin typeface="Arial"/>
-                <a:ea typeface="Arial"/>
-                <a:cs typeface="Arial"/>
-                <a:sym typeface="Arial"/>
-              </a:defRPr>
-            </a:lvl7pPr>
-            <a:lvl8pPr algn="ctr" indent="0" lvl="7" marL="0">
-              <a:spcBef>
-                <a:spcPts val="0"/>
-              </a:spcBef>
-              <a:buNone/>
-              <a:defRPr sz="700">
-                <a:solidFill>
-                  <a:schemeClr val="dk1"/>
-                </a:solidFill>
-                <a:latin typeface="Arial"/>
-                <a:ea typeface="Arial"/>
-                <a:cs typeface="Arial"/>
-                <a:sym typeface="Arial"/>
-              </a:defRPr>
-            </a:lvl8pPr>
-            <a:lvl9pPr algn="ctr" indent="0" lvl="8" marL="0">
-              <a:spcBef>
-                <a:spcPts val="0"/>
-              </a:spcBef>
-              <a:buNone/>
-              <a:defRPr sz="700">
-                <a:solidFill>
-                  <a:schemeClr val="dk1"/>
-                </a:solidFill>
-                <a:latin typeface="Arial"/>
-                <a:ea typeface="Arial"/>
-                <a:cs typeface="Arial"/>
-                <a:sym typeface="Arial"/>
-              </a:defRPr>
-            </a:lvl9pPr>
-          </a:lstStyle>
-          <a:p>
-            <a:pPr algn="ctr" indent="0" lvl="0" marL="0" rtl="0">
-              <a:spcBef>
-                <a:spcPts val="0"/>
-              </a:spcBef>
-              <a:spcAft>
-                <a:spcPts val="0"/>
-              </a:spcAft>
-              <a:buNone/>
-            </a:pPr>
-            <a:fld id="{00000000-1234-1234-1234-123412341234}" type="slidenum">
-              <a:rPr lang="en-US"/>
-              <a:t>‹#›</a:t>
-            </a:fld>
-            <a:endParaRPr/>
-          </a:p>
-        </p:txBody>
-      </p:sp>
-    </p:spTree>
-  </p:cSld>
-</p:sld>
-</file>
-
-<file path=ppt/slides/slide30.xml><?xml version="1.0" encoding="utf-8"?>
+<file path=ppt/slides/slide24.xml><?xml version="1.0" encoding="utf-8"?>
 <p:sld xmlns:a="http://schemas.openxmlformats.org/drawingml/2006/main" xmlns:r="http://schemas.openxmlformats.org/officeDocument/2006/relationships" xmlns:p="http://schemas.openxmlformats.org/presentationml/2006/main">
   <p:cSld>
     <p:spTree>
@@ -52720,244 +50530,7 @@
 </p:sld>
 </file>
 
-<file path=ppt/slides/slide31.xml><?xml version="1.0" encoding="utf-8"?>
-<p:sld xmlns:a="http://schemas.openxmlformats.org/drawingml/2006/main" xmlns:r="http://schemas.openxmlformats.org/officeDocument/2006/relationships" xmlns:p="http://schemas.openxmlformats.org/presentationml/2006/main">
-  <p:cSld>
-    <p:spTree>
-      <p:nvGrpSpPr>
-        <p:cNvPr id="318" name="Shape 318"/>
-        <p:cNvGrpSpPr/>
-        <p:nvPr/>
-      </p:nvGrpSpPr>
-      <p:grpSpPr>
-        <a:xfrm>
-          <a:off x="0" y="0"/>
-          <a:ext cx="0" cy="0"/>
-          <a:chOff x="0" y="0"/>
-          <a:chExt cx="0" cy="0"/>
-        </a:xfrm>
-      </p:grpSpPr>
-      <p:sp>
-        <p:nvSpPr>
-          <p:cNvPr id="332" name="Google Shape;332;p28"/>
-          <p:cNvSpPr txBox="1"/>
-          <p:nvPr>
-            <p:ph type="title"/>
-          </p:nvPr>
-        </p:nvSpPr>
-        <p:spPr>
-          <a:xfrm>
-            <a:off x="1470929" y="2095027"/>
-            <a:ext cx="9941071" cy="884656"/>
-          </a:xfrm>
-          <a:prstGeom prst="rect">
-            <a:avLst/>
-          </a:prstGeom>
-          <a:noFill/>
-          <a:ln>
-            <a:noFill/>
-          </a:ln>
-        </p:spPr>
-        <p:txBody>
-          <a:bodyPr/>
-          <a:lstStyle/>
-          <a:p>
-            <a:pPr lvl="0" indent="0" marL="0">
-              <a:buNone/>
-            </a:pPr>
-            <a:r>
-              <a:rPr/>
-              <a:t>Kết luận</a:t>
-            </a:r>
-          </a:p>
-        </p:txBody>
-      </p:sp>
-      <p:sp>
-        <p:nvSpPr>
-          <p:cNvPr id="347" name="Google Shape;347;p28"/>
-          <p:cNvSpPr txBox="1"/>
-          <p:nvPr>
-            <p:ph idx="12" type="sldNum"/>
-          </p:nvPr>
-        </p:nvSpPr>
-        <p:spPr>
-          <a:xfrm>
-            <a:off x="65862" y="6542216"/>
-            <a:ext cx="292608" cy="315784"/>
-          </a:xfrm>
-          <a:prstGeom prst="rect">
-            <a:avLst/>
-          </a:prstGeom>
-          <a:noFill/>
-          <a:ln>
-            <a:noFill/>
-          </a:ln>
-        </p:spPr>
-        <p:txBody>
-          <a:bodyPr anchor="ctr" anchorCtr="0" bIns="45700" lIns="91425" rIns="91425" spcFirstLastPara="1" tIns="45700" wrap="square">
-            <a:noAutofit/>
-          </a:bodyPr>
-          <a:lstStyle>
-            <a:lvl1pPr algn="ctr" indent="0" lvl="0" marL="0">
-              <a:spcBef>
-                <a:spcPts val="0"/>
-              </a:spcBef>
-              <a:buNone/>
-              <a:defRPr sz="700">
-                <a:solidFill>
-                  <a:schemeClr val="dk1"/>
-                </a:solidFill>
-                <a:latin typeface="Arial"/>
-                <a:ea typeface="Arial"/>
-                <a:cs typeface="Arial"/>
-                <a:sym typeface="Arial"/>
-              </a:defRPr>
-            </a:lvl1pPr>
-            <a:lvl2pPr algn="ctr" indent="0" lvl="1" marL="0">
-              <a:spcBef>
-                <a:spcPts val="0"/>
-              </a:spcBef>
-              <a:buNone/>
-              <a:defRPr sz="700">
-                <a:solidFill>
-                  <a:schemeClr val="dk1"/>
-                </a:solidFill>
-                <a:latin typeface="Arial"/>
-                <a:ea typeface="Arial"/>
-                <a:cs typeface="Arial"/>
-                <a:sym typeface="Arial"/>
-              </a:defRPr>
-            </a:lvl2pPr>
-            <a:lvl3pPr algn="ctr" indent="0" lvl="2" marL="0">
-              <a:spcBef>
-                <a:spcPts val="0"/>
-              </a:spcBef>
-              <a:buNone/>
-              <a:defRPr sz="700">
-                <a:solidFill>
-                  <a:schemeClr val="dk1"/>
-                </a:solidFill>
-                <a:latin typeface="Arial"/>
-                <a:ea typeface="Arial"/>
-                <a:cs typeface="Arial"/>
-                <a:sym typeface="Arial"/>
-              </a:defRPr>
-            </a:lvl3pPr>
-            <a:lvl4pPr algn="ctr" indent="0" lvl="3" marL="0">
-              <a:spcBef>
-                <a:spcPts val="0"/>
-              </a:spcBef>
-              <a:buNone/>
-              <a:defRPr sz="700">
-                <a:solidFill>
-                  <a:schemeClr val="dk1"/>
-                </a:solidFill>
-                <a:latin typeface="Arial"/>
-                <a:ea typeface="Arial"/>
-                <a:cs typeface="Arial"/>
-                <a:sym typeface="Arial"/>
-              </a:defRPr>
-            </a:lvl4pPr>
-            <a:lvl5pPr algn="ctr" indent="0" lvl="4" marL="0">
-              <a:spcBef>
-                <a:spcPts val="0"/>
-              </a:spcBef>
-              <a:buNone/>
-              <a:defRPr sz="700">
-                <a:solidFill>
-                  <a:schemeClr val="dk1"/>
-                </a:solidFill>
-                <a:latin typeface="Arial"/>
-                <a:ea typeface="Arial"/>
-                <a:cs typeface="Arial"/>
-                <a:sym typeface="Arial"/>
-              </a:defRPr>
-            </a:lvl5pPr>
-            <a:lvl6pPr algn="ctr" indent="0" lvl="5" marL="0">
-              <a:spcBef>
-                <a:spcPts val="0"/>
-              </a:spcBef>
-              <a:buNone/>
-              <a:defRPr sz="700">
-                <a:solidFill>
-                  <a:schemeClr val="dk1"/>
-                </a:solidFill>
-                <a:latin typeface="Arial"/>
-                <a:ea typeface="Arial"/>
-                <a:cs typeface="Arial"/>
-                <a:sym typeface="Arial"/>
-              </a:defRPr>
-            </a:lvl6pPr>
-            <a:lvl7pPr algn="ctr" indent="0" lvl="6" marL="0">
-              <a:spcBef>
-                <a:spcPts val="0"/>
-              </a:spcBef>
-              <a:buNone/>
-              <a:defRPr sz="700">
-                <a:solidFill>
-                  <a:schemeClr val="dk1"/>
-                </a:solidFill>
-                <a:latin typeface="Arial"/>
-                <a:ea typeface="Arial"/>
-                <a:cs typeface="Arial"/>
-                <a:sym typeface="Arial"/>
-              </a:defRPr>
-            </a:lvl7pPr>
-            <a:lvl8pPr algn="ctr" indent="0" lvl="7" marL="0">
-              <a:spcBef>
-                <a:spcPts val="0"/>
-              </a:spcBef>
-              <a:buNone/>
-              <a:defRPr sz="700">
-                <a:solidFill>
-                  <a:schemeClr val="dk1"/>
-                </a:solidFill>
-                <a:latin typeface="Arial"/>
-                <a:ea typeface="Arial"/>
-                <a:cs typeface="Arial"/>
-                <a:sym typeface="Arial"/>
-              </a:defRPr>
-            </a:lvl8pPr>
-            <a:lvl9pPr algn="ctr" indent="0" lvl="8" marL="0">
-              <a:spcBef>
-                <a:spcPts val="0"/>
-              </a:spcBef>
-              <a:buNone/>
-              <a:defRPr sz="700">
-                <a:solidFill>
-                  <a:schemeClr val="dk1"/>
-                </a:solidFill>
-                <a:latin typeface="Arial"/>
-                <a:ea typeface="Arial"/>
-                <a:cs typeface="Arial"/>
-                <a:sym typeface="Arial"/>
-              </a:defRPr>
-            </a:lvl9pPr>
-          </a:lstStyle>
-          <a:p>
-            <a:pPr algn="ctr" indent="0" lvl="0" marL="0" rtl="0">
-              <a:spcBef>
-                <a:spcPts val="0"/>
-              </a:spcBef>
-              <a:spcAft>
-                <a:spcPts val="0"/>
-              </a:spcAft>
-              <a:buNone/>
-            </a:pPr>
-            <a:fld id="{00000000-1234-1234-1234-123412341234}" type="slidenum">
-              <a:rPr lang="en-US"/>
-              <a:t>‹#›</a:t>
-            </a:fld>
-            <a:endParaRPr/>
-          </a:p>
-        </p:txBody>
-      </p:sp>
-    </p:spTree>
-  </p:cSld>
-</p:sld>
-</file>
-
-<file path=ppt/slides/slide32.xml><?xml version="1.0" encoding="utf-8"?>
+<file path=ppt/slides/slide25.xml><?xml version="1.0" encoding="utf-8"?>
 <p:sld xmlns:a="http://schemas.openxmlformats.org/drawingml/2006/main" xmlns:r="http://schemas.openxmlformats.org/officeDocument/2006/relationships" xmlns:p="http://schemas.openxmlformats.org/presentationml/2006/main">
   <p:cSld>
     <p:spTree>
@@ -53633,7 +51206,7 @@
 </p:sld>
 </file>
 
-<file path=ppt/slides/slide33.xml><?xml version="1.0" encoding="utf-8"?>
+<file path=ppt/slides/slide26.xml><?xml version="1.0" encoding="utf-8"?>
 <p:sld xmlns:a="http://schemas.openxmlformats.org/drawingml/2006/main" xmlns:r="http://schemas.openxmlformats.org/officeDocument/2006/relationships" xmlns:p="http://schemas.openxmlformats.org/presentationml/2006/main">
   <p:cSld>
     <p:spTree>
@@ -54084,7 +51657,7 @@
 </p:sld>
 </file>
 
-<file path=ppt/slides/slide34.xml><?xml version="1.0" encoding="utf-8"?>
+<file path=ppt/slides/slide27.xml><?xml version="1.0" encoding="utf-8"?>
 <p:sld xmlns:a="http://schemas.openxmlformats.org/drawingml/2006/main" xmlns:r="http://schemas.openxmlformats.org/officeDocument/2006/relationships" xmlns:p="http://schemas.openxmlformats.org/presentationml/2006/main">
   <p:cSld>
     <p:spTree>
@@ -54535,7 +52108,7 @@
 </p:sld>
 </file>
 
-<file path=ppt/slides/slide35.xml><?xml version="1.0" encoding="utf-8"?>
+<file path=ppt/slides/slide28.xml><?xml version="1.0" encoding="utf-8"?>
 <p:sld xmlns:a="http://schemas.openxmlformats.org/drawingml/2006/main" xmlns:r="http://schemas.openxmlformats.org/officeDocument/2006/relationships" xmlns:p="http://schemas.openxmlformats.org/presentationml/2006/main">
   <p:cSld>
     <p:spTree>
@@ -54860,7 +52433,7 @@
 </p:sld>
 </file>
 
-<file path=ppt/slides/slide36.xml><?xml version="1.0" encoding="utf-8"?>
+<file path=ppt/slides/slide29.xml><?xml version="1.0" encoding="utf-8"?>
 <p:sld xmlns:a="http://schemas.openxmlformats.org/drawingml/2006/main" xmlns:r="http://schemas.openxmlformats.org/officeDocument/2006/relationships" xmlns:p="http://schemas.openxmlformats.org/presentationml/2006/main">
   <p:cSld>
     <p:spTree>
@@ -55219,7 +52792,335 @@
 </p:sld>
 </file>
 
-<file path=ppt/slides/slide37.xml><?xml version="1.0" encoding="utf-8"?>
+<file path=ppt/slides/slide3.xml><?xml version="1.0" encoding="utf-8"?>
+<p:sld xmlns:a="http://schemas.openxmlformats.org/drawingml/2006/main" xmlns:r="http://schemas.openxmlformats.org/officeDocument/2006/relationships" xmlns:p="http://schemas.openxmlformats.org/presentationml/2006/main">
+  <p:cSld>
+    <p:spTree>
+      <p:nvGrpSpPr>
+        <p:cNvPr id="428" name="Shape 428"/>
+        <p:cNvGrpSpPr/>
+        <p:nvPr/>
+      </p:nvGrpSpPr>
+      <p:grpSpPr>
+        <a:xfrm>
+          <a:off x="0" y="0"/>
+          <a:ext cx="0" cy="0"/>
+          <a:chOff x="0" y="0"/>
+          <a:chExt cx="0" cy="0"/>
+        </a:xfrm>
+      </p:grpSpPr>
+      <p:sp>
+        <p:nvSpPr>
+          <p:cNvPr id="436" name="Google Shape;436;p31"/>
+          <p:cNvSpPr txBox="1"/>
+          <p:nvPr>
+            <p:ph type="title"/>
+          </p:nvPr>
+        </p:nvSpPr>
+        <p:spPr>
+          <a:xfrm>
+            <a:off x="774146" y="202009"/>
+            <a:ext cx="3932227" cy="1698043"/>
+          </a:xfrm>
+          <a:prstGeom prst="rect">
+            <a:avLst/>
+          </a:prstGeom>
+          <a:noFill/>
+          <a:ln>
+            <a:noFill/>
+          </a:ln>
+        </p:spPr>
+        <p:txBody>
+          <a:bodyPr/>
+          <a:lstStyle/>
+          <a:p>
+            <a:pPr lvl="0" indent="0" marL="0">
+              <a:buNone/>
+            </a:pPr>
+            <a:r>
+              <a:rPr/>
+              <a:t>Vì sao đề tài này</a:t>
+            </a:r>
+          </a:p>
+        </p:txBody>
+      </p:sp>
+      <p:sp>
+        <p:nvSpPr>
+          <p:cNvPr id="437" name="Google Shape;437;p31"/>
+          <p:cNvSpPr txBox="1"/>
+          <p:nvPr>
+            <p:ph idx="2" sz="half" type="body"/>
+          </p:nvPr>
+        </p:nvSpPr>
+        <p:spPr/>
+        <p:txBody>
+          <a:bodyPr/>
+          <a:lstStyle/>
+          <a:p>
+            <a:pPr lvl="0" indent="0" marL="0">
+              <a:buNone/>
+            </a:pPr>
+            <a:r>
+              <a:rPr b="1"/>
+              <a:t>~77 triệu xe máy</a:t>
+            </a:r>
+            <a:r>
+              <a:rPr/>
+              <a:t> — </a:t>
+            </a:r>
+            <a:r>
+              <a:rPr b="1"/>
+              <a:t>85–90%</a:t>
+            </a:r>
+            <a:r>
+              <a:rPr/>
+              <a:t> lưu lượng đường bộ Việt Nam</a:t>
+            </a:r>
+          </a:p>
+          <a:p>
+            <a:pPr lvl="0" indent="0" marL="0">
+              <a:buNone/>
+            </a:pPr>
+            <a:r>
+              <a:rPr/>
+              <a:t>Cùng hệ thống, cùng phép đo: </a:t>
+            </a:r>
+            <a:r>
+              <a:rPr b="1"/>
+              <a:t>chênh 48,6 điểm</a:t>
+            </a:r>
+            <a:r>
+              <a:rPr/>
+              <a:t>, chỉ khác bố cục</a:t>
+            </a:r>
+          </a:p>
+          <a:p>
+            <a:pPr lvl="0" indent="0" marL="0">
+              <a:buNone/>
+            </a:pPr>
+            <a:r>
+              <a:rPr i="1"/>
+              <a:t>Số liệu Brazil, không phải Việt Nam</a:t>
+            </a:r>
+          </a:p>
+        </p:txBody>
+      </p:sp>
+      <p:pic>
+        <p:nvPicPr>
+          <p:cNvPr descr="figures/fig-gap.png" id="0" name="Picture 1"/>
+          <p:cNvPicPr>
+            <a:picLocks noGrp="1" noChangeAspect="1"/>
+          </p:cNvPicPr>
+          <p:nvPr/>
+        </p:nvPicPr>
+        <p:blipFill>
+          <a:blip r:embed="rId2"/>
+          <a:stretch>
+            <a:fillRect/>
+          </a:stretch>
+        </p:blipFill>
+        <p:spPr bwMode="auto">
+          <a:xfrm>
+            <a:off x="5156200" y="787400"/>
+            <a:ext cx="6235700" cy="4762500"/>
+          </a:xfrm>
+          <a:prstGeom prst="rect">
+            <a:avLst/>
+          </a:prstGeom>
+          <a:noFill/>
+          <a:ln w="9525">
+            <a:noFill/>
+            <a:headEnd/>
+            <a:tailEnd/>
+          </a:ln>
+        </p:spPr>
+      </p:pic>
+      <p:sp>
+        <p:nvSpPr>
+          <p:cNvPr id="449" name="Google Shape;449;p31"/>
+          <p:cNvSpPr txBox="1"/>
+          <p:nvPr>
+            <p:ph idx="12" type="sldNum"/>
+          </p:nvPr>
+        </p:nvSpPr>
+        <p:spPr>
+          <a:xfrm>
+            <a:off x="58380" y="6508358"/>
+            <a:ext cx="349642" cy="349642"/>
+          </a:xfrm>
+          <a:prstGeom prst="rect">
+            <a:avLst/>
+          </a:prstGeom>
+          <a:noFill/>
+          <a:ln>
+            <a:noFill/>
+          </a:ln>
+        </p:spPr>
+        <p:txBody>
+          <a:bodyPr anchor="ctr" anchorCtr="0" bIns="45700" lIns="91425" rIns="91425" spcFirstLastPara="1" tIns="45700" wrap="square">
+            <a:noAutofit/>
+          </a:bodyPr>
+          <a:lstStyle>
+            <a:lvl1pPr algn="ctr" indent="0" lvl="0" marL="0">
+              <a:spcBef>
+                <a:spcPts val="0"/>
+              </a:spcBef>
+              <a:buNone/>
+              <a:defRPr sz="700">
+                <a:solidFill>
+                  <a:schemeClr val="dk1"/>
+                </a:solidFill>
+                <a:latin typeface="Arial"/>
+                <a:ea typeface="Arial"/>
+                <a:cs typeface="Arial"/>
+                <a:sym typeface="Arial"/>
+              </a:defRPr>
+            </a:lvl1pPr>
+            <a:lvl2pPr algn="ctr" indent="0" lvl="1" marL="0">
+              <a:spcBef>
+                <a:spcPts val="0"/>
+              </a:spcBef>
+              <a:buNone/>
+              <a:defRPr sz="700">
+                <a:solidFill>
+                  <a:schemeClr val="dk1"/>
+                </a:solidFill>
+                <a:latin typeface="Arial"/>
+                <a:ea typeface="Arial"/>
+                <a:cs typeface="Arial"/>
+                <a:sym typeface="Arial"/>
+              </a:defRPr>
+            </a:lvl2pPr>
+            <a:lvl3pPr algn="ctr" indent="0" lvl="2" marL="0">
+              <a:spcBef>
+                <a:spcPts val="0"/>
+              </a:spcBef>
+              <a:buNone/>
+              <a:defRPr sz="700">
+                <a:solidFill>
+                  <a:schemeClr val="dk1"/>
+                </a:solidFill>
+                <a:latin typeface="Arial"/>
+                <a:ea typeface="Arial"/>
+                <a:cs typeface="Arial"/>
+                <a:sym typeface="Arial"/>
+              </a:defRPr>
+            </a:lvl3pPr>
+            <a:lvl4pPr algn="ctr" indent="0" lvl="3" marL="0">
+              <a:spcBef>
+                <a:spcPts val="0"/>
+              </a:spcBef>
+              <a:buNone/>
+              <a:defRPr sz="700">
+                <a:solidFill>
+                  <a:schemeClr val="dk1"/>
+                </a:solidFill>
+                <a:latin typeface="Arial"/>
+                <a:ea typeface="Arial"/>
+                <a:cs typeface="Arial"/>
+                <a:sym typeface="Arial"/>
+              </a:defRPr>
+            </a:lvl4pPr>
+            <a:lvl5pPr algn="ctr" indent="0" lvl="4" marL="0">
+              <a:spcBef>
+                <a:spcPts val="0"/>
+              </a:spcBef>
+              <a:buNone/>
+              <a:defRPr sz="700">
+                <a:solidFill>
+                  <a:schemeClr val="dk1"/>
+                </a:solidFill>
+                <a:latin typeface="Arial"/>
+                <a:ea typeface="Arial"/>
+                <a:cs typeface="Arial"/>
+                <a:sym typeface="Arial"/>
+              </a:defRPr>
+            </a:lvl5pPr>
+            <a:lvl6pPr algn="ctr" indent="0" lvl="5" marL="0">
+              <a:spcBef>
+                <a:spcPts val="0"/>
+              </a:spcBef>
+              <a:buNone/>
+              <a:defRPr sz="700">
+                <a:solidFill>
+                  <a:schemeClr val="dk1"/>
+                </a:solidFill>
+                <a:latin typeface="Arial"/>
+                <a:ea typeface="Arial"/>
+                <a:cs typeface="Arial"/>
+                <a:sym typeface="Arial"/>
+              </a:defRPr>
+            </a:lvl6pPr>
+            <a:lvl7pPr algn="ctr" indent="0" lvl="6" marL="0">
+              <a:spcBef>
+                <a:spcPts val="0"/>
+              </a:spcBef>
+              <a:buNone/>
+              <a:defRPr sz="700">
+                <a:solidFill>
+                  <a:schemeClr val="dk1"/>
+                </a:solidFill>
+                <a:latin typeface="Arial"/>
+                <a:ea typeface="Arial"/>
+                <a:cs typeface="Arial"/>
+                <a:sym typeface="Arial"/>
+              </a:defRPr>
+            </a:lvl7pPr>
+            <a:lvl8pPr algn="ctr" indent="0" lvl="7" marL="0">
+              <a:spcBef>
+                <a:spcPts val="0"/>
+              </a:spcBef>
+              <a:buNone/>
+              <a:defRPr sz="700">
+                <a:solidFill>
+                  <a:schemeClr val="dk1"/>
+                </a:solidFill>
+                <a:latin typeface="Arial"/>
+                <a:ea typeface="Arial"/>
+                <a:cs typeface="Arial"/>
+                <a:sym typeface="Arial"/>
+              </a:defRPr>
+            </a:lvl8pPr>
+            <a:lvl9pPr algn="ctr" indent="0" lvl="8" marL="0">
+              <a:spcBef>
+                <a:spcPts val="0"/>
+              </a:spcBef>
+              <a:buNone/>
+              <a:defRPr sz="700">
+                <a:solidFill>
+                  <a:schemeClr val="dk1"/>
+                </a:solidFill>
+                <a:latin typeface="Arial"/>
+                <a:ea typeface="Arial"/>
+                <a:cs typeface="Arial"/>
+                <a:sym typeface="Arial"/>
+              </a:defRPr>
+            </a:lvl9pPr>
+          </a:lstStyle>
+          <a:p>
+            <a:pPr algn="ctr" indent="0" lvl="0" marL="0" rtl="0">
+              <a:spcBef>
+                <a:spcPts val="0"/>
+              </a:spcBef>
+              <a:spcAft>
+                <a:spcPts val="0"/>
+              </a:spcAft>
+              <a:buNone/>
+            </a:pPr>
+            <a:fld id="{00000000-1234-1234-1234-123412341234}" type="slidenum">
+              <a:rPr lang="en-US"/>
+              <a:t>‹#›</a:t>
+            </a:fld>
+            <a:endParaRPr/>
+          </a:p>
+        </p:txBody>
+      </p:sp>
+    </p:spTree>
+  </p:cSld>
+</p:sld>
+</file>
+
+<file path=ppt/slides/slide30.xml><?xml version="1.0" encoding="utf-8"?>
 <p:sld xmlns:a="http://schemas.openxmlformats.org/drawingml/2006/main" xmlns:r="http://schemas.openxmlformats.org/officeDocument/2006/relationships" xmlns:p="http://schemas.openxmlformats.org/presentationml/2006/main">
   <p:cSld>
     <p:spTree>
@@ -56060,243 +53961,6 @@
   <p:cSld>
     <p:spTree>
       <p:nvGrpSpPr>
-        <p:cNvPr id="318" name="Shape 318"/>
-        <p:cNvGrpSpPr/>
-        <p:nvPr/>
-      </p:nvGrpSpPr>
-      <p:grpSpPr>
-        <a:xfrm>
-          <a:off x="0" y="0"/>
-          <a:ext cx="0" cy="0"/>
-          <a:chOff x="0" y="0"/>
-          <a:chExt cx="0" cy="0"/>
-        </a:xfrm>
-      </p:grpSpPr>
-      <p:sp>
-        <p:nvSpPr>
-          <p:cNvPr id="332" name="Google Shape;332;p28"/>
-          <p:cNvSpPr txBox="1"/>
-          <p:nvPr>
-            <p:ph type="title"/>
-          </p:nvPr>
-        </p:nvSpPr>
-        <p:spPr>
-          <a:xfrm>
-            <a:off x="1470929" y="2095027"/>
-            <a:ext cx="9941071" cy="884656"/>
-          </a:xfrm>
-          <a:prstGeom prst="rect">
-            <a:avLst/>
-          </a:prstGeom>
-          <a:noFill/>
-          <a:ln>
-            <a:noFill/>
-          </a:ln>
-        </p:spPr>
-        <p:txBody>
-          <a:bodyPr/>
-          <a:lstStyle/>
-          <a:p>
-            <a:pPr lvl="0" indent="0" marL="0">
-              <a:buNone/>
-            </a:pPr>
-            <a:r>
-              <a:rPr/>
-              <a:t>Nền tảng</a:t>
-            </a:r>
-          </a:p>
-        </p:txBody>
-      </p:sp>
-      <p:sp>
-        <p:nvSpPr>
-          <p:cNvPr id="347" name="Google Shape;347;p28"/>
-          <p:cNvSpPr txBox="1"/>
-          <p:nvPr>
-            <p:ph idx="12" type="sldNum"/>
-          </p:nvPr>
-        </p:nvSpPr>
-        <p:spPr>
-          <a:xfrm>
-            <a:off x="65862" y="6542216"/>
-            <a:ext cx="292608" cy="315784"/>
-          </a:xfrm>
-          <a:prstGeom prst="rect">
-            <a:avLst/>
-          </a:prstGeom>
-          <a:noFill/>
-          <a:ln>
-            <a:noFill/>
-          </a:ln>
-        </p:spPr>
-        <p:txBody>
-          <a:bodyPr anchor="ctr" anchorCtr="0" bIns="45700" lIns="91425" rIns="91425" spcFirstLastPara="1" tIns="45700" wrap="square">
-            <a:noAutofit/>
-          </a:bodyPr>
-          <a:lstStyle>
-            <a:lvl1pPr algn="ctr" indent="0" lvl="0" marL="0">
-              <a:spcBef>
-                <a:spcPts val="0"/>
-              </a:spcBef>
-              <a:buNone/>
-              <a:defRPr sz="700">
-                <a:solidFill>
-                  <a:schemeClr val="dk1"/>
-                </a:solidFill>
-                <a:latin typeface="Arial"/>
-                <a:ea typeface="Arial"/>
-                <a:cs typeface="Arial"/>
-                <a:sym typeface="Arial"/>
-              </a:defRPr>
-            </a:lvl1pPr>
-            <a:lvl2pPr algn="ctr" indent="0" lvl="1" marL="0">
-              <a:spcBef>
-                <a:spcPts val="0"/>
-              </a:spcBef>
-              <a:buNone/>
-              <a:defRPr sz="700">
-                <a:solidFill>
-                  <a:schemeClr val="dk1"/>
-                </a:solidFill>
-                <a:latin typeface="Arial"/>
-                <a:ea typeface="Arial"/>
-                <a:cs typeface="Arial"/>
-                <a:sym typeface="Arial"/>
-              </a:defRPr>
-            </a:lvl2pPr>
-            <a:lvl3pPr algn="ctr" indent="0" lvl="2" marL="0">
-              <a:spcBef>
-                <a:spcPts val="0"/>
-              </a:spcBef>
-              <a:buNone/>
-              <a:defRPr sz="700">
-                <a:solidFill>
-                  <a:schemeClr val="dk1"/>
-                </a:solidFill>
-                <a:latin typeface="Arial"/>
-                <a:ea typeface="Arial"/>
-                <a:cs typeface="Arial"/>
-                <a:sym typeface="Arial"/>
-              </a:defRPr>
-            </a:lvl3pPr>
-            <a:lvl4pPr algn="ctr" indent="0" lvl="3" marL="0">
-              <a:spcBef>
-                <a:spcPts val="0"/>
-              </a:spcBef>
-              <a:buNone/>
-              <a:defRPr sz="700">
-                <a:solidFill>
-                  <a:schemeClr val="dk1"/>
-                </a:solidFill>
-                <a:latin typeface="Arial"/>
-                <a:ea typeface="Arial"/>
-                <a:cs typeface="Arial"/>
-                <a:sym typeface="Arial"/>
-              </a:defRPr>
-            </a:lvl4pPr>
-            <a:lvl5pPr algn="ctr" indent="0" lvl="4" marL="0">
-              <a:spcBef>
-                <a:spcPts val="0"/>
-              </a:spcBef>
-              <a:buNone/>
-              <a:defRPr sz="700">
-                <a:solidFill>
-                  <a:schemeClr val="dk1"/>
-                </a:solidFill>
-                <a:latin typeface="Arial"/>
-                <a:ea typeface="Arial"/>
-                <a:cs typeface="Arial"/>
-                <a:sym typeface="Arial"/>
-              </a:defRPr>
-            </a:lvl5pPr>
-            <a:lvl6pPr algn="ctr" indent="0" lvl="5" marL="0">
-              <a:spcBef>
-                <a:spcPts val="0"/>
-              </a:spcBef>
-              <a:buNone/>
-              <a:defRPr sz="700">
-                <a:solidFill>
-                  <a:schemeClr val="dk1"/>
-                </a:solidFill>
-                <a:latin typeface="Arial"/>
-                <a:ea typeface="Arial"/>
-                <a:cs typeface="Arial"/>
-                <a:sym typeface="Arial"/>
-              </a:defRPr>
-            </a:lvl6pPr>
-            <a:lvl7pPr algn="ctr" indent="0" lvl="6" marL="0">
-              <a:spcBef>
-                <a:spcPts val="0"/>
-              </a:spcBef>
-              <a:buNone/>
-              <a:defRPr sz="700">
-                <a:solidFill>
-                  <a:schemeClr val="dk1"/>
-                </a:solidFill>
-                <a:latin typeface="Arial"/>
-                <a:ea typeface="Arial"/>
-                <a:cs typeface="Arial"/>
-                <a:sym typeface="Arial"/>
-              </a:defRPr>
-            </a:lvl7pPr>
-            <a:lvl8pPr algn="ctr" indent="0" lvl="7" marL="0">
-              <a:spcBef>
-                <a:spcPts val="0"/>
-              </a:spcBef>
-              <a:buNone/>
-              <a:defRPr sz="700">
-                <a:solidFill>
-                  <a:schemeClr val="dk1"/>
-                </a:solidFill>
-                <a:latin typeface="Arial"/>
-                <a:ea typeface="Arial"/>
-                <a:cs typeface="Arial"/>
-                <a:sym typeface="Arial"/>
-              </a:defRPr>
-            </a:lvl8pPr>
-            <a:lvl9pPr algn="ctr" indent="0" lvl="8" marL="0">
-              <a:spcBef>
-                <a:spcPts val="0"/>
-              </a:spcBef>
-              <a:buNone/>
-              <a:defRPr sz="700">
-                <a:solidFill>
-                  <a:schemeClr val="dk1"/>
-                </a:solidFill>
-                <a:latin typeface="Arial"/>
-                <a:ea typeface="Arial"/>
-                <a:cs typeface="Arial"/>
-                <a:sym typeface="Arial"/>
-              </a:defRPr>
-            </a:lvl9pPr>
-          </a:lstStyle>
-          <a:p>
-            <a:pPr algn="ctr" indent="0" lvl="0" marL="0" rtl="0">
-              <a:spcBef>
-                <a:spcPts val="0"/>
-              </a:spcBef>
-              <a:spcAft>
-                <a:spcPts val="0"/>
-              </a:spcAft>
-              <a:buNone/>
-            </a:pPr>
-            <a:fld id="{00000000-1234-1234-1234-123412341234}" type="slidenum">
-              <a:rPr lang="en-US"/>
-              <a:t>‹#›</a:t>
-            </a:fld>
-            <a:endParaRPr/>
-          </a:p>
-        </p:txBody>
-      </p:sp>
-    </p:spTree>
-  </p:cSld>
-</p:sld>
-</file>
-
-<file path=ppt/slides/slide6.xml><?xml version="1.0" encoding="utf-8"?>
-<p:sld xmlns:a="http://schemas.openxmlformats.org/drawingml/2006/main" xmlns:r="http://schemas.openxmlformats.org/officeDocument/2006/relationships" xmlns:p="http://schemas.openxmlformats.org/presentationml/2006/main">
-  <p:cSld>
-    <p:spTree>
-      <p:nvGrpSpPr>
         <p:cNvPr id="428" name="Shape 428"/>
         <p:cNvGrpSpPr/>
         <p:nvPr/>
@@ -56758,7 +54422,7 @@
 </p:sld>
 </file>
 
-<file path=ppt/slides/slide7.xml><?xml version="1.0" encoding="utf-8"?>
+<file path=ppt/slides/slide6.xml><?xml version="1.0" encoding="utf-8"?>
 <p:sld xmlns:a="http://schemas.openxmlformats.org/drawingml/2006/main" xmlns:r="http://schemas.openxmlformats.org/officeDocument/2006/relationships" xmlns:p="http://schemas.openxmlformats.org/presentationml/2006/main">
   <p:cSld>
     <p:spTree>
@@ -57085,7 +54749,7 @@
 </p:sld>
 </file>
 
-<file path=ppt/slides/slide8.xml><?xml version="1.0" encoding="utf-8"?>
+<file path=ppt/slides/slide7.xml><?xml version="1.0" encoding="utf-8"?>
 <p:sld xmlns:a="http://schemas.openxmlformats.org/drawingml/2006/main" xmlns:r="http://schemas.openxmlformats.org/officeDocument/2006/relationships" xmlns:p="http://schemas.openxmlformats.org/presentationml/2006/main">
   <p:cSld>
     <p:spTree>
@@ -57407,12 +55071,12 @@
 </p:sld>
 </file>
 
-<file path=ppt/slides/slide9.xml><?xml version="1.0" encoding="utf-8"?>
+<file path=ppt/slides/slide8.xml><?xml version="1.0" encoding="utf-8"?>
 <p:sld xmlns:a="http://schemas.openxmlformats.org/drawingml/2006/main" xmlns:r="http://schemas.openxmlformats.org/officeDocument/2006/relationships" xmlns:p="http://schemas.openxmlformats.org/presentationml/2006/main">
   <p:cSld>
     <p:spTree>
       <p:nvGrpSpPr>
-        <p:cNvPr id="318" name="Shape 318"/>
+        <p:cNvPr id="428" name="Shape 428"/>
         <p:cNvGrpSpPr/>
         <p:nvPr/>
       </p:nvGrpSpPr>
@@ -57426,7 +55090,7 @@
       </p:grpSpPr>
       <p:sp>
         <p:nvSpPr>
-          <p:cNvPr id="332" name="Google Shape;332;p28"/>
+          <p:cNvPr id="436" name="Google Shape;436;p31"/>
           <p:cNvSpPr txBox="1"/>
           <p:nvPr>
             <p:ph type="title"/>
@@ -57434,8 +55098,8 @@
         </p:nvSpPr>
         <p:spPr>
           <a:xfrm>
-            <a:off x="1470929" y="2095027"/>
-            <a:ext cx="9941071" cy="884656"/>
+            <a:off x="774146" y="202009"/>
+            <a:ext cx="3932227" cy="1698043"/>
           </a:xfrm>
           <a:prstGeom prst="rect">
             <a:avLst/>
@@ -57454,14 +55118,275 @@
             </a:pPr>
             <a:r>
               <a:rPr/>
-              <a:t>Thiết kế</a:t>
+              <a:t>Kiến trúc 5 tầng</a:t>
             </a:r>
           </a:p>
         </p:txBody>
       </p:sp>
       <p:sp>
         <p:nvSpPr>
-          <p:cNvPr id="347" name="Google Shape;347;p28"/>
+          <p:cNvPr id="437" name="Google Shape;437;p31"/>
+          <p:cNvSpPr txBox="1"/>
+          <p:nvPr>
+            <p:ph idx="2" sz="half" type="body"/>
+          </p:nvPr>
+        </p:nvSpPr>
+        <p:spPr/>
+        <p:txBody>
+          <a:bodyPr/>
+          <a:lstStyle/>
+          <a:p>
+            <a:pPr lvl="0" indent="0" marL="0">
+              <a:buNone/>
+            </a:pPr>
+            <a:r>
+              <a:rPr/>
+              <a:t>Tầng AI là </a:t>
+            </a:r>
+            <a:r>
+              <a:rPr b="1"/>
+              <a:t>Python thuần</a:t>
+            </a:r>
+            <a:r>
+              <a:rPr/>
+              <a:t> — cấm import FastAPI hoặc Pydantic. Nó không có mũi tên nào đi lên, nên thay engine OCR </a:t>
+            </a:r>
+            <a:r>
+              <a:rPr b="1"/>
+              <a:t>không đụng một dòng mã API</a:t>
+            </a:r>
+          </a:p>
+        </p:txBody>
+      </p:sp>
+      <p:graphicFrame>
+        <p:nvGraphicFramePr>
+          <p:cNvPr id="6" name="Content Placeholder 5"/>
+          <p:cNvGraphicFramePr>
+            <a:graphicFrameLocks noGrp="1"/>
+          </p:cNvGraphicFramePr>
+          <p:nvPr>
+            <p:ph idx="1"/>
+          </p:nvPr>
+        </p:nvGraphicFramePr>
+        <p:xfrm>
+          <a:off x="5156200" y="190500"/>
+          <a:ext cx="6235700" cy="5969000"/>
+        </p:xfrm>
+        <a:graphic>
+          <a:graphicData uri="http://schemas.openxmlformats.org/drawingml/2006/table">
+            <a:tbl>
+              <a:tblPr firstRow="1" bandRow="1">
+                <a:tableStyleId>{45BEF19B-5B1D-4A26-B267-ECC71EF7E2D4}</a:tableStyleId>
+              </a:tblPr>
+              <a:tblGrid>
+                <a:gridCol w="3111500"/>
+                <a:gridCol w="3111500"/>
+              </a:tblGrid>
+              <a:tr h="0">
+                <a:tc>
+                  <a:txBody>
+                    <a:bodyPr/>
+                    <a:lstStyle/>
+                    <a:p>
+                      <a:pPr lvl="0" indent="0" marL="0">
+                        <a:buNone/>
+                      </a:pPr>
+                      <a:r>
+                        <a:rPr/>
+                        <a:t>Tầng</a:t>
+                      </a:r>
+                    </a:p>
+                  </a:txBody>
+                  <a:tcPr/>
+                </a:tc>
+                <a:tc>
+                  <a:txBody>
+                    <a:bodyPr/>
+                    <a:lstStyle/>
+                    <a:p>
+                      <a:pPr lvl="0" indent="0" marL="0">
+                        <a:buNone/>
+                      </a:pPr>
+                      <a:r>
+                        <a:rPr/>
+                        <a:t>Công nghệ</a:t>
+                      </a:r>
+                    </a:p>
+                  </a:txBody>
+                  <a:tcPr/>
+                </a:tc>
+              </a:tr>
+              <a:tr h="0">
+                <a:tc>
+                  <a:txBody>
+                    <a:bodyPr/>
+                    <a:lstStyle/>
+                    <a:p>
+                      <a:pPr lvl="0" indent="0" marL="0">
+                        <a:buNone/>
+                      </a:pPr>
+                      <a:r>
+                        <a:rPr/>
+                        <a:t>L1 — Trình bày</a:t>
+                      </a:r>
+                    </a:p>
+                  </a:txBody>
+                </a:tc>
+                <a:tc>
+                  <a:txBody>
+                    <a:bodyPr/>
+                    <a:lstStyle/>
+                    <a:p>
+                      <a:pPr lvl="0" indent="0" marL="0">
+                        <a:buNone/>
+                      </a:pPr>
+                      <a:r>
+                        <a:rPr/>
+                        <a:t>React + TypeScript + Tailwind · 3 trang</a:t>
+                      </a:r>
+                    </a:p>
+                  </a:txBody>
+                </a:tc>
+              </a:tr>
+              <a:tr h="0">
+                <a:tc>
+                  <a:txBody>
+                    <a:bodyPr/>
+                    <a:lstStyle/>
+                    <a:p>
+                      <a:pPr lvl="0" indent="0" marL="0">
+                        <a:buNone/>
+                      </a:pPr>
+                      <a:r>
+                        <a:rPr/>
+                        <a:t>L2 — API</a:t>
+                      </a:r>
+                    </a:p>
+                  </a:txBody>
+                </a:tc>
+                <a:tc>
+                  <a:txBody>
+                    <a:bodyPr/>
+                    <a:lstStyle/>
+                    <a:p>
+                      <a:pPr lvl="0" indent="0" marL="0">
+                        <a:buNone/>
+                      </a:pPr>
+                      <a:r>
+                        <a:rPr/>
+                        <a:t>FastAPI + Swagger · 10 endpoint</a:t>
+                      </a:r>
+                    </a:p>
+                  </a:txBody>
+                </a:tc>
+              </a:tr>
+              <a:tr h="0">
+                <a:tc>
+                  <a:txBody>
+                    <a:bodyPr/>
+                    <a:lstStyle/>
+                    <a:p>
+                      <a:pPr lvl="0" indent="0" marL="0">
+                        <a:buNone/>
+                      </a:pPr>
+                      <a:r>
+                        <a:rPr/>
+                        <a:t>L3 — Nghiệp vụ</a:t>
+                      </a:r>
+                    </a:p>
+                  </a:txBody>
+                </a:tc>
+                <a:tc>
+                  <a:txBody>
+                    <a:bodyPr/>
+                    <a:lstStyle/>
+                    <a:p>
+                      <a:pPr lvl="0" indent="0" marL="0">
+                        <a:buNone/>
+                      </a:pPr>
+                      <a:r>
+                        <a:rPr/>
+                        <a:t>Detection / Video / History / Storage</a:t>
+                      </a:r>
+                    </a:p>
+                  </a:txBody>
+                </a:tc>
+              </a:tr>
+              <a:tr h="0">
+                <a:tc>
+                  <a:txBody>
+                    <a:bodyPr/>
+                    <a:lstStyle/>
+                    <a:p>
+                      <a:pPr lvl="0" indent="0" marL="0">
+                        <a:buNone/>
+                      </a:pPr>
+                      <a:r>
+                        <a:rPr b="1"/>
+                        <a:t>L4 — AI</a:t>
+                      </a:r>
+                    </a:p>
+                  </a:txBody>
+                </a:tc>
+                <a:tc>
+                  <a:txBody>
+                    <a:bodyPr/>
+                    <a:lstStyle/>
+                    <a:p>
+                      <a:pPr lvl="0" indent="0" marL="0">
+                        <a:buNone/>
+                      </a:pPr>
+                      <a:r>
+                        <a:rPr b="1"/>
+                        <a:t>Python thuần</a:t>
+                      </a:r>
+                      <a:r>
+                        <a:rPr/>
+                        <a:t> — YOLO11 + PaddleOCR + Normalizer</a:t>
+                      </a:r>
+                    </a:p>
+                  </a:txBody>
+                </a:tc>
+              </a:tr>
+              <a:tr h="0">
+                <a:tc>
+                  <a:txBody>
+                    <a:bodyPr/>
+                    <a:lstStyle/>
+                    <a:p>
+                      <a:pPr lvl="0" indent="0" marL="0">
+                        <a:buNone/>
+                      </a:pPr>
+                      <a:r>
+                        <a:rPr/>
+                        <a:t>L5 — Dữ liệu</a:t>
+                      </a:r>
+                    </a:p>
+                  </a:txBody>
+                </a:tc>
+                <a:tc>
+                  <a:txBody>
+                    <a:bodyPr/>
+                    <a:lstStyle/>
+                    <a:p>
+                      <a:pPr lvl="0" indent="0" marL="0">
+                        <a:buNone/>
+                      </a:pPr>
+                      <a:r>
+                        <a:rPr/>
+                        <a:t>SQLite + SQLAlchemy + Alembic</a:t>
+                      </a:r>
+                    </a:p>
+                  </a:txBody>
+                </a:tc>
+              </a:tr>
+            </a:tbl>
+          </a:graphicData>
+        </a:graphic>
+      </p:graphicFrame>
+      <p:sp>
+        <p:nvSpPr>
+          <p:cNvPr id="449" name="Google Shape;449;p31"/>
           <p:cNvSpPr txBox="1"/>
           <p:nvPr>
             <p:ph idx="12" type="sldNum"/>
@@ -57469,8 +55394,482 @@
         </p:nvSpPr>
         <p:spPr>
           <a:xfrm>
-            <a:off x="65862" y="6542216"/>
-            <a:ext cx="292608" cy="315784"/>
+            <a:off x="58380" y="6508358"/>
+            <a:ext cx="349642" cy="349642"/>
+          </a:xfrm>
+          <a:prstGeom prst="rect">
+            <a:avLst/>
+          </a:prstGeom>
+          <a:noFill/>
+          <a:ln>
+            <a:noFill/>
+          </a:ln>
+        </p:spPr>
+        <p:txBody>
+          <a:bodyPr anchor="ctr" anchorCtr="0" bIns="45700" lIns="91425" rIns="91425" spcFirstLastPara="1" tIns="45700" wrap="square">
+            <a:noAutofit/>
+          </a:bodyPr>
+          <a:lstStyle>
+            <a:lvl1pPr algn="ctr" indent="0" lvl="0" marL="0">
+              <a:spcBef>
+                <a:spcPts val="0"/>
+              </a:spcBef>
+              <a:buNone/>
+              <a:defRPr sz="700">
+                <a:solidFill>
+                  <a:schemeClr val="dk1"/>
+                </a:solidFill>
+                <a:latin typeface="Arial"/>
+                <a:ea typeface="Arial"/>
+                <a:cs typeface="Arial"/>
+                <a:sym typeface="Arial"/>
+              </a:defRPr>
+            </a:lvl1pPr>
+            <a:lvl2pPr algn="ctr" indent="0" lvl="1" marL="0">
+              <a:spcBef>
+                <a:spcPts val="0"/>
+              </a:spcBef>
+              <a:buNone/>
+              <a:defRPr sz="700">
+                <a:solidFill>
+                  <a:schemeClr val="dk1"/>
+                </a:solidFill>
+                <a:latin typeface="Arial"/>
+                <a:ea typeface="Arial"/>
+                <a:cs typeface="Arial"/>
+                <a:sym typeface="Arial"/>
+              </a:defRPr>
+            </a:lvl2pPr>
+            <a:lvl3pPr algn="ctr" indent="0" lvl="2" marL="0">
+              <a:spcBef>
+                <a:spcPts val="0"/>
+              </a:spcBef>
+              <a:buNone/>
+              <a:defRPr sz="700">
+                <a:solidFill>
+                  <a:schemeClr val="dk1"/>
+                </a:solidFill>
+                <a:latin typeface="Arial"/>
+                <a:ea typeface="Arial"/>
+                <a:cs typeface="Arial"/>
+                <a:sym typeface="Arial"/>
+              </a:defRPr>
+            </a:lvl3pPr>
+            <a:lvl4pPr algn="ctr" indent="0" lvl="3" marL="0">
+              <a:spcBef>
+                <a:spcPts val="0"/>
+              </a:spcBef>
+              <a:buNone/>
+              <a:defRPr sz="700">
+                <a:solidFill>
+                  <a:schemeClr val="dk1"/>
+                </a:solidFill>
+                <a:latin typeface="Arial"/>
+                <a:ea typeface="Arial"/>
+                <a:cs typeface="Arial"/>
+                <a:sym typeface="Arial"/>
+              </a:defRPr>
+            </a:lvl4pPr>
+            <a:lvl5pPr algn="ctr" indent="0" lvl="4" marL="0">
+              <a:spcBef>
+                <a:spcPts val="0"/>
+              </a:spcBef>
+              <a:buNone/>
+              <a:defRPr sz="700">
+                <a:solidFill>
+                  <a:schemeClr val="dk1"/>
+                </a:solidFill>
+                <a:latin typeface="Arial"/>
+                <a:ea typeface="Arial"/>
+                <a:cs typeface="Arial"/>
+                <a:sym typeface="Arial"/>
+              </a:defRPr>
+            </a:lvl5pPr>
+            <a:lvl6pPr algn="ctr" indent="0" lvl="5" marL="0">
+              <a:spcBef>
+                <a:spcPts val="0"/>
+              </a:spcBef>
+              <a:buNone/>
+              <a:defRPr sz="700">
+                <a:solidFill>
+                  <a:schemeClr val="dk1"/>
+                </a:solidFill>
+                <a:latin typeface="Arial"/>
+                <a:ea typeface="Arial"/>
+                <a:cs typeface="Arial"/>
+                <a:sym typeface="Arial"/>
+              </a:defRPr>
+            </a:lvl6pPr>
+            <a:lvl7pPr algn="ctr" indent="0" lvl="6" marL="0">
+              <a:spcBef>
+                <a:spcPts val="0"/>
+              </a:spcBef>
+              <a:buNone/>
+              <a:defRPr sz="700">
+                <a:solidFill>
+                  <a:schemeClr val="dk1"/>
+                </a:solidFill>
+                <a:latin typeface="Arial"/>
+                <a:ea typeface="Arial"/>
+                <a:cs typeface="Arial"/>
+                <a:sym typeface="Arial"/>
+              </a:defRPr>
+            </a:lvl7pPr>
+            <a:lvl8pPr algn="ctr" indent="0" lvl="7" marL="0">
+              <a:spcBef>
+                <a:spcPts val="0"/>
+              </a:spcBef>
+              <a:buNone/>
+              <a:defRPr sz="700">
+                <a:solidFill>
+                  <a:schemeClr val="dk1"/>
+                </a:solidFill>
+                <a:latin typeface="Arial"/>
+                <a:ea typeface="Arial"/>
+                <a:cs typeface="Arial"/>
+                <a:sym typeface="Arial"/>
+              </a:defRPr>
+            </a:lvl8pPr>
+            <a:lvl9pPr algn="ctr" indent="0" lvl="8" marL="0">
+              <a:spcBef>
+                <a:spcPts val="0"/>
+              </a:spcBef>
+              <a:buNone/>
+              <a:defRPr sz="700">
+                <a:solidFill>
+                  <a:schemeClr val="dk1"/>
+                </a:solidFill>
+                <a:latin typeface="Arial"/>
+                <a:ea typeface="Arial"/>
+                <a:cs typeface="Arial"/>
+                <a:sym typeface="Arial"/>
+              </a:defRPr>
+            </a:lvl9pPr>
+          </a:lstStyle>
+          <a:p>
+            <a:pPr algn="ctr" indent="0" lvl="0" marL="0" rtl="0">
+              <a:spcBef>
+                <a:spcPts val="0"/>
+              </a:spcBef>
+              <a:spcAft>
+                <a:spcPts val="0"/>
+              </a:spcAft>
+              <a:buNone/>
+            </a:pPr>
+            <a:fld id="{00000000-1234-1234-1234-123412341234}" type="slidenum">
+              <a:rPr lang="en-US"/>
+              <a:t>‹#›</a:t>
+            </a:fld>
+            <a:endParaRPr/>
+          </a:p>
+        </p:txBody>
+      </p:sp>
+    </p:spTree>
+  </p:cSld>
+</p:sld>
+</file>
+
+<file path=ppt/slides/slide9.xml><?xml version="1.0" encoding="utf-8"?>
+<p:sld xmlns:a="http://schemas.openxmlformats.org/drawingml/2006/main" xmlns:r="http://schemas.openxmlformats.org/officeDocument/2006/relationships" xmlns:p="http://schemas.openxmlformats.org/presentationml/2006/main">
+  <p:cSld>
+    <p:spTree>
+      <p:nvGrpSpPr>
+        <p:cNvPr id="428" name="Shape 428"/>
+        <p:cNvGrpSpPr/>
+        <p:nvPr/>
+      </p:nvGrpSpPr>
+      <p:grpSpPr>
+        <a:xfrm>
+          <a:off x="0" y="0"/>
+          <a:ext cx="0" cy="0"/>
+          <a:chOff x="0" y="0"/>
+          <a:chExt cx="0" cy="0"/>
+        </a:xfrm>
+      </p:grpSpPr>
+      <p:sp>
+        <p:nvSpPr>
+          <p:cNvPr id="436" name="Google Shape;436;p31"/>
+          <p:cNvSpPr txBox="1"/>
+          <p:nvPr>
+            <p:ph type="title"/>
+          </p:nvPr>
+        </p:nvSpPr>
+        <p:spPr>
+          <a:xfrm>
+            <a:off x="774146" y="202009"/>
+            <a:ext cx="3932227" cy="1698043"/>
+          </a:xfrm>
+          <a:prstGeom prst="rect">
+            <a:avLst/>
+          </a:prstGeom>
+          <a:noFill/>
+          <a:ln>
+            <a:noFill/>
+          </a:ln>
+        </p:spPr>
+        <p:txBody>
+          <a:bodyPr/>
+          <a:lstStyle/>
+          <a:p>
+            <a:pPr lvl="0" indent="0" marL="0">
+              <a:buNone/>
+            </a:pPr>
+            <a:r>
+              <a:rPr/>
+              <a:t>Cơ sở dữ liệu — một cột làm nên đóng góp</a:t>
+            </a:r>
+          </a:p>
+        </p:txBody>
+      </p:sp>
+      <p:sp>
+        <p:nvSpPr>
+          <p:cNvPr id="437" name="Google Shape;437;p31"/>
+          <p:cNvSpPr txBox="1"/>
+          <p:nvPr>
+            <p:ph idx="2" sz="half" type="body"/>
+          </p:nvPr>
+        </p:nvSpPr>
+        <p:spPr/>
+        <p:txBody>
+          <a:bodyPr/>
+          <a:lstStyle/>
+          <a:p>
+            <a:pPr lvl="0" indent="0" marL="0">
+              <a:buNone/>
+            </a:pPr>
+            <a:r>
+              <a:rPr/>
+              <a:t>Lưu </a:t>
+            </a:r>
+            <a:r>
+              <a:rPr b="1"/>
+              <a:t>cả hai</a:t>
+            </a:r>
+            <a:r>
+              <a:rPr/>
+              <a:t> chuỗi trên </a:t>
+            </a:r>
+            <a:r>
+              <a:rPr b="1"/>
+              <a:t>cùng một bản ghi</a:t>
+            </a:r>
+            <a:r>
+              <a:rPr/>
+              <a:t> — không có </a:t>
+            </a:r>
+            <a:r>
+              <a:rPr>
+                <a:latin typeface="Courier"/>
+              </a:rPr>
+              <a:t>raw_ocr_text</a:t>
+            </a:r>
+            <a:r>
+              <a:rPr/>
+              <a:t> thì </a:t>
+            </a:r>
+            <a:r>
+              <a:rPr b="1"/>
+              <a:t>không đo được</a:t>
+            </a:r>
+            <a:r>
+              <a:rPr/>
+              <a:t> đóng góp của hậu xử lý</a:t>
+            </a:r>
+          </a:p>
+        </p:txBody>
+      </p:sp>
+      <p:graphicFrame>
+        <p:nvGraphicFramePr>
+          <p:cNvPr id="6" name="Content Placeholder 5"/>
+          <p:cNvGraphicFramePr>
+            <a:graphicFrameLocks noGrp="1"/>
+          </p:cNvGraphicFramePr>
+          <p:nvPr>
+            <p:ph idx="1"/>
+          </p:nvPr>
+        </p:nvGraphicFramePr>
+        <p:xfrm>
+          <a:off x="5156200" y="190500"/>
+          <a:ext cx="6235700" cy="5969000"/>
+        </p:xfrm>
+        <a:graphic>
+          <a:graphicData uri="http://schemas.openxmlformats.org/drawingml/2006/table">
+            <a:tbl>
+              <a:tblPr firstRow="1" bandRow="1">
+                <a:tableStyleId>{45BEF19B-5B1D-4A26-B267-ECC71EF7E2D4}</a:tableStyleId>
+              </a:tblPr>
+              <a:tblGrid>
+                <a:gridCol w="3111500"/>
+                <a:gridCol w="3111500"/>
+              </a:tblGrid>
+              <a:tr h="0">
+                <a:tc>
+                  <a:txBody>
+                    <a:bodyPr/>
+                    <a:lstStyle/>
+                    <a:p>
+                      <a:pPr lvl="0" indent="0" marL="0">
+                        <a:buNone/>
+                      </a:pPr>
+                      <a:r>
+                        <a:rPr/>
+                        <a:t>Cột</a:t>
+                      </a:r>
+                    </a:p>
+                  </a:txBody>
+                  <a:tcPr/>
+                </a:tc>
+                <a:tc>
+                  <a:txBody>
+                    <a:bodyPr/>
+                    <a:lstStyle/>
+                    <a:p>
+                      <a:pPr lvl="0" indent="0" marL="0">
+                        <a:buNone/>
+                      </a:pPr>
+                      <a:r>
+                        <a:rPr/>
+                        <a:t>Nội dung</a:t>
+                      </a:r>
+                    </a:p>
+                  </a:txBody>
+                  <a:tcPr/>
+                </a:tc>
+              </a:tr>
+              <a:tr h="0">
+                <a:tc>
+                  <a:txBody>
+                    <a:bodyPr/>
+                    <a:lstStyle/>
+                    <a:p>
+                      <a:pPr lvl="0" indent="0" marL="0">
+                        <a:buNone/>
+                      </a:pPr>
+                      <a:r>
+                        <a:rPr>
+                          <a:latin typeface="Courier"/>
+                        </a:rPr>
+                        <a:t>raw_ocr_text</a:t>
+                      </a:r>
+                    </a:p>
+                  </a:txBody>
+                </a:tc>
+                <a:tc>
+                  <a:txBody>
+                    <a:bodyPr/>
+                    <a:lstStyle/>
+                    <a:p>
+                      <a:pPr lvl="0" indent="0" marL="0">
+                        <a:buNone/>
+                      </a:pPr>
+                      <a:r>
+                        <a:rPr/>
+                        <a:t>Chuỗi </a:t>
+                      </a:r>
+                      <a:r>
+                        <a:rPr b="1"/>
+                        <a:t>thô</a:t>
+                      </a:r>
+                      <a:r>
+                        <a:rPr/>
+                        <a:t> do PaddleOCR trả về</a:t>
+                      </a:r>
+                    </a:p>
+                  </a:txBody>
+                </a:tc>
+              </a:tr>
+              <a:tr h="0">
+                <a:tc>
+                  <a:txBody>
+                    <a:bodyPr/>
+                    <a:lstStyle/>
+                    <a:p>
+                      <a:pPr lvl="0" indent="0" marL="0">
+                        <a:buNone/>
+                      </a:pPr>
+                      <a:r>
+                        <a:rPr>
+                          <a:latin typeface="Courier"/>
+                        </a:rPr>
+                        <a:t>plate_number</a:t>
+                      </a:r>
+                    </a:p>
+                  </a:txBody>
+                </a:tc>
+                <a:tc>
+                  <a:txBody>
+                    <a:bodyPr/>
+                    <a:lstStyle/>
+                    <a:p>
+                      <a:pPr lvl="0" indent="0" marL="0">
+                        <a:buNone/>
+                      </a:pPr>
+                      <a:r>
+                        <a:rPr/>
+                        <a:t>Chuỗi </a:t>
+                      </a:r>
+                      <a:r>
+                        <a:rPr b="1"/>
+                        <a:t>sau</a:t>
+                      </a:r>
+                      <a:r>
+                        <a:rPr/>
+                        <a:t> bộ luật hậu xử lý</a:t>
+                      </a:r>
+                    </a:p>
+                  </a:txBody>
+                </a:tc>
+              </a:tr>
+              <a:tr h="0">
+                <a:tc>
+                  <a:txBody>
+                    <a:bodyPr/>
+                    <a:lstStyle/>
+                    <a:p>
+                      <a:pPr lvl="0" indent="0" marL="0">
+                        <a:buNone/>
+                      </a:pPr>
+                      <a:r>
+                        <a:rPr>
+                          <a:latin typeface="Courier"/>
+                        </a:rPr>
+                        <a:t>is_valid_format</a:t>
+                      </a:r>
+                    </a:p>
+                  </a:txBody>
+                </a:tc>
+                <a:tc>
+                  <a:txBody>
+                    <a:bodyPr/>
+                    <a:lstStyle/>
+                    <a:p>
+                      <a:pPr lvl="0" indent="0" marL="0">
+                        <a:buNone/>
+                      </a:pPr>
+                      <a:r>
+                        <a:rPr/>
+                        <a:t>Hợp quy cách Việt Nam hay không</a:t>
+                      </a:r>
+                    </a:p>
+                  </a:txBody>
+                </a:tc>
+              </a:tr>
+            </a:tbl>
+          </a:graphicData>
+        </a:graphic>
+      </p:graphicFrame>
+      <p:sp>
+        <p:nvSpPr>
+          <p:cNvPr id="449" name="Google Shape;449;p31"/>
+          <p:cNvSpPr txBox="1"/>
+          <p:nvPr>
+            <p:ph idx="12" type="sldNum"/>
+          </p:nvPr>
+        </p:nvSpPr>
+        <p:spPr>
+          <a:xfrm>
+            <a:off x="58380" y="6508358"/>
+            <a:ext cx="349642" cy="349642"/>
           </a:xfrm>
           <a:prstGeom prst="rect">
             <a:avLst/>

</xml_diff>

<commit_message>
Sơ đồ pipeline thành hình vẽ thay cho khối ASCII
Slide Pipeline trước đó chở một khối mã đơn cách. Nó đọc tệ khi chiếu: các ký
tự vẽ khung phụ thuộc vào phông giữ được cột thẳng hàng, mà chủ đề trình bày
không bảo đảm điều đó — và toàn bộ cấu trúc nhánh biến mất ngay khi một dòng
xuống hàng. Chính lỗi này đã xảy ra thật trước khi bỏ căn đều trong template.

Vẽ ra thì nhánh biển 2 dòng — đóng góp kỹ thuật lõi của đồ án — nhìn thấy
ngay bằng màu đỏ, thay vì nằm lẫn giữa một khối chữ.

Bản đầu vẽ xong lại quá nhỏ để đọc từ cuối phòng. Nguyên nhân: một chú thích
chạy dài sang phải kéo khung rộng ra, mà ô nội dung của layout chỉ khoảng
654 px, nên mọi phần thừa bề ngang đều biến thành chữ nhỏ đi khi hình được
thu vào đó. Chuyển chú thích sang phần chữ của slide, thu khung từ 9,2 xuống
7,4 và phóng chữ từ 11,5 lên 14,5.

30 slide, 0 chỗ tràn — đo bằng PowerPoint COM.

Co-Authored-By: Claude Fable 5 <noreply@anthropic.com>
</commit_message>
<xml_diff>
--- a/docs/slides/slides.pptx
+++ b/docs/slides/slides.pptx
@@ -43982,7 +43982,7 @@
   <p:cSld>
     <p:spTree>
       <p:nvGrpSpPr>
-        <p:cNvPr id="134" name="Shape 134"/>
+        <p:cNvPr id="428" name="Shape 428"/>
         <p:cNvGrpSpPr/>
         <p:nvPr/>
       </p:nvGrpSpPr>
@@ -43996,7 +43996,7 @@
       </p:grpSpPr>
       <p:sp>
         <p:nvSpPr>
-          <p:cNvPr id="142" name="Google Shape;142;p23"/>
+          <p:cNvPr id="436" name="Google Shape;436;p31"/>
           <p:cNvSpPr txBox="1"/>
           <p:nvPr>
             <p:ph type="title"/>
@@ -44004,8 +44004,8 @@
         </p:nvSpPr>
         <p:spPr>
           <a:xfrm>
-            <a:off x="774145" y="223964"/>
-            <a:ext cx="10579655" cy="785896"/>
+            <a:off x="774146" y="202009"/>
+            <a:ext cx="3932227" cy="1698043"/>
           </a:xfrm>
           <a:prstGeom prst="rect">
             <a:avLst/>
@@ -44031,16 +44031,33 @@
       </p:sp>
       <p:sp>
         <p:nvSpPr>
-          <p:cNvPr id="143" name="Google Shape;143;p23"/>
+          <p:cNvPr id="437" name="Google Shape;437;p31"/>
           <p:cNvSpPr txBox="1"/>
           <p:nvPr>
-            <p:ph idx="1"/>
+            <p:ph idx="2" sz="half" type="body"/>
           </p:nvPr>
         </p:nvSpPr>
         <p:spPr/>
         <p:txBody>
           <a:bodyPr/>
           <a:lstStyle/>
+          <a:p>
+            <a:pPr lvl="0" indent="0" marL="0">
+              <a:buNone/>
+            </a:pPr>
+            <a:r>
+              <a:rPr/>
+              <a:t>Nhánh </a:t>
+            </a:r>
+            <a:r>
+              <a:rPr b="1"/>
+              <a:t>đỏ</a:t>
+            </a:r>
+            <a:r>
+              <a:rPr/>
+              <a:t> là đóng góp kỹ thuật lõi</a:t>
+            </a:r>
+          </a:p>
           <a:p>
             <a:pPr lvl="0" indent="0" marL="0">
               <a:buNone/>
@@ -44058,27 +44075,41 @@
               <a:t> — không phải lỗi</a:t>
             </a:r>
           </a:p>
-          <a:p>
-            <a:pPr lvl="0" indent="0">
-              <a:buNone/>
-            </a:pPr>
-            <a:r>
-              <a:rPr>
-                <a:latin typeface="Courier"/>
-              </a:rPr>
-              <a:t>Ảnh → YOLO11n phát hiện → cắt vùng biển
-    → phân loại số dòng (ngưỡng tỉ lệ 2,5)
-        ├─ 1 dòng → PaddleOCR
-        └─ 2 dòng → nắn hình → tách → ghép ngang → PaddleOCR
-    → chuẩn hoá + sửa lỗi theo VỊ TRÍ → kiểm tra hợp lệ
-    → lưu CẢ chuỗi thô LẪN chuỗi đã sửa</a:t>
-            </a:r>
-          </a:p>
         </p:txBody>
       </p:sp>
+      <p:pic>
+        <p:nvPicPr>
+          <p:cNvPr descr="figures/fig-pipeline.png" id="0" name="Picture 1"/>
+          <p:cNvPicPr>
+            <a:picLocks noGrp="1" noChangeAspect="1"/>
+          </p:cNvPicPr>
+          <p:nvPr/>
+        </p:nvPicPr>
+        <p:blipFill>
+          <a:blip r:embed="rId2"/>
+          <a:stretch>
+            <a:fillRect/>
+          </a:stretch>
+        </p:blipFill>
+        <p:spPr bwMode="auto">
+          <a:xfrm>
+            <a:off x="5156200" y="228600"/>
+            <a:ext cx="6235700" cy="5880100"/>
+          </a:xfrm>
+          <a:prstGeom prst="rect">
+            <a:avLst/>
+          </a:prstGeom>
+          <a:noFill/>
+          <a:ln w="9525">
+            <a:noFill/>
+            <a:headEnd/>
+            <a:tailEnd/>
+          </a:ln>
+        </p:spPr>
+      </p:pic>
       <p:sp>
         <p:nvSpPr>
-          <p:cNvPr id="155" name="Google Shape;155;p23"/>
+          <p:cNvPr id="449" name="Google Shape;449;p31"/>
           <p:cNvSpPr txBox="1"/>
           <p:nvPr>
             <p:ph idx="12" type="sldNum"/>

</xml_diff>

<commit_message>
docs: them hai slide du phong tra loi "vi sao PaddleOCR v5 mobile"
Deck nhac PaddleOCR ba lan nhung khong giai thich lan nao -- khong noi vi sao
PaddleOCR thay vi EasyOCR, cung khong noi vi sao ban v5 mobile thay vi v6.
Slide "Chon huong tiep can" chi so THE HE KIEN TRUC, khong so engine.

Ca hai deu la cau hoi hoi dong rat de hoi, nen dat o phan du phong sau slide
Cam on, dung cho hoi dap:

  34. Vi sao PaddleOCR — va vi sao ban v5 mobile
  35. v6 chinh xac hon — vi sao van khong doi

Trong luc lam da vi pham chinh quy uoc so 2 cua file (bang phai la khoi CUOI
cung): dat cau ket luan sau bang nen pandoc cat roi no. Da chuyen len tren bang.
Ghi lai vi day la lan thu hai mac cung loi do.

35 slide, 0 loi tran/de nhau.

Co-Authored-By: Claude Opus 5 <noreply@anthropic.com>
</commit_message>
<xml_diff>
--- a/docs/slides/slides.pptx
+++ b/docs/slides/slides.pptx
@@ -38,23 +38,25 @@
     <p:sldId id="286" r:id="rId35"/>
     <p:sldId id="287" r:id="rId36"/>
     <p:sldId id="288" r:id="rId37"/>
+    <p:sldId id="289" r:id="rId38"/>
+    <p:sldId id="290" r:id="rId39"/>
   </p:sldIdLst>
   <p:sldSz cx="12192000" cy="6858000"/>
   <p:notesSz cx="6858000" cy="9144000"/>
   <p:embeddedFontLst>
     <p:embeddedFont>
       <p:font typeface="Roboto"/>
-      <p:regular r:id="rId38"/>
-      <p:bold r:id="rId39"/>
-      <p:italic r:id="rId40"/>
-      <p:boldItalic r:id="rId41"/>
+      <p:regular r:id="rId40"/>
+      <p:bold r:id="rId41"/>
+      <p:italic r:id="rId42"/>
+      <p:boldItalic r:id="rId43"/>
     </p:embeddedFont>
     <p:embeddedFont>
       <p:font typeface="Open Sans"/>
-      <p:regular r:id="rId42"/>
-      <p:bold r:id="rId43"/>
-      <p:italic r:id="rId44"/>
-      <p:boldItalic r:id="rId45"/>
+      <p:regular r:id="rId44"/>
+      <p:bold r:id="rId45"/>
+      <p:italic r:id="rId46"/>
+      <p:boldItalic r:id="rId47"/>
     </p:embeddedFont>
   </p:embeddedFontLst>
   <p:defaultTextStyle>
@@ -288,7 +290,7 @@
   </p:defaultTextStyle>
   <p:extLst>
     <p:ext uri="GoogleSlidesCustomDataVersion2">
-      <go:slidesCustomData xmlns:go="http://customooxmlschemas.google.com/" roundtripDataSignature="AMtx7mhu5dURU4INwSlvEO7StWDXKr50jg==" r:id="rId46"/>
+      <go:slidesCustomData xmlns:go="http://customooxmlschemas.google.com/" roundtripDataSignature="AMtx7mhu5dURU4INwSlvEO7StWDXKr50jg==" r:id="rId48"/>
     </p:ext>
   </p:extLst>
 </p:presentation>
@@ -54918,6 +54920,902 @@
 </p:sld>
 </file>
 
+<file path=ppt/slides/slide34.xml><?xml version="1.0" encoding="utf-8"?>
+<p:sld xmlns:a="http://schemas.openxmlformats.org/drawingml/2006/main" xmlns:r="http://schemas.openxmlformats.org/officeDocument/2006/relationships" xmlns:p="http://schemas.openxmlformats.org/presentationml/2006/main">
+  <p:cSld>
+    <p:spTree>
+      <p:nvGrpSpPr>
+        <p:cNvPr id="428" name="Shape 428"/>
+        <p:cNvGrpSpPr/>
+        <p:nvPr/>
+      </p:nvGrpSpPr>
+      <p:grpSpPr>
+        <a:xfrm>
+          <a:off x="0" y="0"/>
+          <a:ext cx="0" cy="0"/>
+          <a:chOff x="0" y="0"/>
+          <a:chExt cx="0" cy="0"/>
+        </a:xfrm>
+      </p:grpSpPr>
+      <p:sp>
+        <p:nvSpPr>
+          <p:cNvPr id="436" name="Google Shape;436;p31"/>
+          <p:cNvSpPr txBox="1"/>
+          <p:nvPr>
+            <p:ph type="title"/>
+          </p:nvPr>
+        </p:nvSpPr>
+        <p:spPr>
+          <a:xfrm>
+            <a:off x="771525" y="200025"/>
+            <a:ext cx="10582275" cy="790575"/>
+          </a:xfrm>
+          <a:prstGeom prst="rect">
+            <a:avLst/>
+          </a:prstGeom>
+          <a:noFill/>
+          <a:ln>
+            <a:noFill/>
+          </a:ln>
+        </p:spPr>
+        <p:txBody>
+          <a:bodyPr/>
+          <a:lstStyle/>
+          <a:p>
+            <a:pPr lvl="0" indent="0" marL="0">
+              <a:buNone/>
+            </a:pPr>
+            <a:r>
+              <a:rPr/>
+              <a:t>Vì sao PaddleOCR — và vì sao bản v5 mobile</a:t>
+            </a:r>
+          </a:p>
+        </p:txBody>
+      </p:sp>
+      <p:sp>
+        <p:nvSpPr>
+          <p:cNvPr id="437" name="Google Shape;437;p31"/>
+          <p:cNvSpPr txBox="1"/>
+          <p:nvPr>
+            <p:ph idx="2" sz="half" type="body"/>
+          </p:nvPr>
+        </p:nvSpPr>
+        <p:spPr/>
+        <p:txBody>
+          <a:bodyPr/>
+          <a:lstStyle/>
+          <a:p>
+            <a:pPr lvl="0" indent="0" marL="0">
+              <a:buNone/>
+            </a:pPr>
+            <a:r>
+              <a:rPr/>
+              <a:t>Lý do </a:t>
+            </a:r>
+            <a:r>
+              <a:rPr b="1"/>
+              <a:t>kỹ thuật</a:t>
+            </a:r>
+            <a:r>
+              <a:rPr/>
+              <a:t>, không phải độ chính xác — nhẹ hơn EasyOCR ~10 lần</a:t>
+            </a:r>
+          </a:p>
+        </p:txBody>
+      </p:sp>
+      <p:graphicFrame>
+        <p:nvGraphicFramePr>
+          <p:cNvPr id="6" name="Content Placeholder 5"/>
+          <p:cNvGraphicFramePr>
+            <a:graphicFrameLocks noGrp="1"/>
+          </p:cNvGraphicFramePr>
+          <p:nvPr>
+            <p:ph idx="1"/>
+          </p:nvPr>
+        </p:nvGraphicFramePr>
+        <p:xfrm>
+          <a:off x="762000" y="2209800"/>
+          <a:ext cx="10579100" cy="3962400"/>
+        </p:xfrm>
+        <a:graphic>
+          <a:graphicData uri="http://schemas.openxmlformats.org/drawingml/2006/table">
+            <a:tbl>
+              <a:tblPr firstRow="1" bandRow="1">
+                <a:tableStyleId>{45BEF19B-5B1D-4A26-B267-ECC71EF7E2D4}</a:tableStyleId>
+              </a:tblPr>
+              <a:tblGrid>
+                <a:gridCol w="3517900"/>
+                <a:gridCol w="3517900"/>
+                <a:gridCol w="3517900"/>
+              </a:tblGrid>
+              <a:tr h="0">
+                <a:tc>
+                  <a:txBody>
+                    <a:bodyPr/>
+                    <a:lstStyle/>
+                    <a:p>
+                      <a:endParaRPr/>
+                    </a:p>
+                  </a:txBody>
+                  <a:tcPr/>
+                </a:tc>
+                <a:tc>
+                  <a:txBody>
+                    <a:bodyPr/>
+                    <a:lstStyle/>
+                    <a:p>
+                      <a:pPr lvl="0" indent="0" marL="0" algn="r">
+                        <a:buNone/>
+                      </a:pPr>
+                      <a:r>
+                        <a:rPr/>
+                        <a:t>Chuỗi đúng</a:t>
+                      </a:r>
+                    </a:p>
+                  </a:txBody>
+                  <a:tcPr/>
+                </a:tc>
+                <a:tc>
+                  <a:txBody>
+                    <a:bodyPr/>
+                    <a:lstStyle/>
+                    <a:p>
+                      <a:pPr lvl="0" indent="0" marL="0" algn="r">
+                        <a:buNone/>
+                      </a:pPr>
+                      <a:r>
+                        <a:rPr/>
+                        <a:t>Trung vị</a:t>
+                      </a:r>
+                    </a:p>
+                  </a:txBody>
+                  <a:tcPr/>
+                </a:tc>
+              </a:tr>
+              <a:tr h="0">
+                <a:tc>
+                  <a:txBody>
+                    <a:bodyPr/>
+                    <a:lstStyle/>
+                    <a:p>
+                      <a:pPr lvl="0" indent="0" marL="0">
+                        <a:buNone/>
+                      </a:pPr>
+                      <a:r>
+                        <a:rPr b="1"/>
+                        <a:t>PP-OCRv5_mobile</a:t>
+                      </a:r>
+                      <a:r>
+                        <a:rPr/>
+                        <a:t> — đang dùng</a:t>
+                      </a:r>
+                    </a:p>
+                  </a:txBody>
+                </a:tc>
+                <a:tc>
+                  <a:txBody>
+                    <a:bodyPr/>
+                    <a:lstStyle/>
+                    <a:p>
+                      <a:pPr lvl="0" indent="0" marL="0" algn="r">
+                        <a:buNone/>
+                      </a:pPr>
+                      <a:r>
+                        <a:rPr/>
+                        <a:t>67,0%</a:t>
+                      </a:r>
+                    </a:p>
+                  </a:txBody>
+                </a:tc>
+                <a:tc>
+                  <a:txBody>
+                    <a:bodyPr/>
+                    <a:lstStyle/>
+                    <a:p>
+                      <a:pPr lvl="0" indent="0" marL="0" algn="r">
+                        <a:buNone/>
+                      </a:pPr>
+                      <a:r>
+                        <a:rPr b="1"/>
+                        <a:t>23,0 ms</a:t>
+                      </a:r>
+                    </a:p>
+                  </a:txBody>
+                </a:tc>
+              </a:tr>
+              <a:tr h="0">
+                <a:tc>
+                  <a:txBody>
+                    <a:bodyPr/>
+                    <a:lstStyle/>
+                    <a:p>
+                      <a:pPr lvl="0" indent="0" marL="0">
+                        <a:buNone/>
+                      </a:pPr>
+                      <a:r>
+                        <a:rPr/>
+                        <a:t>PP-OCRv6_medium</a:t>
+                      </a:r>
+                    </a:p>
+                  </a:txBody>
+                </a:tc>
+                <a:tc>
+                  <a:txBody>
+                    <a:bodyPr/>
+                    <a:lstStyle/>
+                    <a:p>
+                      <a:pPr lvl="0" indent="0" marL="0" algn="r">
+                        <a:buNone/>
+                      </a:pPr>
+                      <a:r>
+                        <a:rPr b="1"/>
+                        <a:t>72,5%</a:t>
+                      </a:r>
+                    </a:p>
+                  </a:txBody>
+                </a:tc>
+                <a:tc>
+                  <a:txBody>
+                    <a:bodyPr/>
+                    <a:lstStyle/>
+                    <a:p>
+                      <a:pPr lvl="0" indent="0" marL="0" algn="r">
+                        <a:buNone/>
+                      </a:pPr>
+                      <a:r>
+                        <a:rPr/>
+                        <a:t>386,9 ms</a:t>
+                      </a:r>
+                    </a:p>
+                  </a:txBody>
+                </a:tc>
+              </a:tr>
+            </a:tbl>
+          </a:graphicData>
+        </a:graphic>
+      </p:graphicFrame>
+      <p:sp>
+        <p:nvSpPr>
+          <p:cNvPr id="449" name="Google Shape;449;p31"/>
+          <p:cNvSpPr txBox="1"/>
+          <p:nvPr>
+            <p:ph idx="12" type="sldNum"/>
+          </p:nvPr>
+        </p:nvSpPr>
+        <p:spPr>
+          <a:xfrm>
+            <a:off x="58380" y="6508358"/>
+            <a:ext cx="349642" cy="349642"/>
+          </a:xfrm>
+          <a:prstGeom prst="rect">
+            <a:avLst/>
+          </a:prstGeom>
+          <a:noFill/>
+          <a:ln>
+            <a:noFill/>
+          </a:ln>
+        </p:spPr>
+        <p:txBody>
+          <a:bodyPr anchor="ctr" anchorCtr="0" bIns="45700" lIns="91425" rIns="91425" spcFirstLastPara="1" tIns="45700" wrap="square">
+            <a:noAutofit/>
+          </a:bodyPr>
+          <a:lstStyle>
+            <a:lvl1pPr algn="ctr" indent="0" lvl="0" marL="0">
+              <a:spcBef>
+                <a:spcPts val="0"/>
+              </a:spcBef>
+              <a:buNone/>
+              <a:defRPr sz="700">
+                <a:solidFill>
+                  <a:schemeClr val="dk1"/>
+                </a:solidFill>
+                <a:latin typeface="Arial"/>
+                <a:ea typeface="Arial"/>
+                <a:cs typeface="Arial"/>
+                <a:sym typeface="Arial"/>
+              </a:defRPr>
+            </a:lvl1pPr>
+            <a:lvl2pPr algn="ctr" indent="0" lvl="1" marL="0">
+              <a:spcBef>
+                <a:spcPts val="0"/>
+              </a:spcBef>
+              <a:buNone/>
+              <a:defRPr sz="700">
+                <a:solidFill>
+                  <a:schemeClr val="dk1"/>
+                </a:solidFill>
+                <a:latin typeface="Arial"/>
+                <a:ea typeface="Arial"/>
+                <a:cs typeface="Arial"/>
+                <a:sym typeface="Arial"/>
+              </a:defRPr>
+            </a:lvl2pPr>
+            <a:lvl3pPr algn="ctr" indent="0" lvl="2" marL="0">
+              <a:spcBef>
+                <a:spcPts val="0"/>
+              </a:spcBef>
+              <a:buNone/>
+              <a:defRPr sz="700">
+                <a:solidFill>
+                  <a:schemeClr val="dk1"/>
+                </a:solidFill>
+                <a:latin typeface="Arial"/>
+                <a:ea typeface="Arial"/>
+                <a:cs typeface="Arial"/>
+                <a:sym typeface="Arial"/>
+              </a:defRPr>
+            </a:lvl3pPr>
+            <a:lvl4pPr algn="ctr" indent="0" lvl="3" marL="0">
+              <a:spcBef>
+                <a:spcPts val="0"/>
+              </a:spcBef>
+              <a:buNone/>
+              <a:defRPr sz="700">
+                <a:solidFill>
+                  <a:schemeClr val="dk1"/>
+                </a:solidFill>
+                <a:latin typeface="Arial"/>
+                <a:ea typeface="Arial"/>
+                <a:cs typeface="Arial"/>
+                <a:sym typeface="Arial"/>
+              </a:defRPr>
+            </a:lvl4pPr>
+            <a:lvl5pPr algn="ctr" indent="0" lvl="4" marL="0">
+              <a:spcBef>
+                <a:spcPts val="0"/>
+              </a:spcBef>
+              <a:buNone/>
+              <a:defRPr sz="700">
+                <a:solidFill>
+                  <a:schemeClr val="dk1"/>
+                </a:solidFill>
+                <a:latin typeface="Arial"/>
+                <a:ea typeface="Arial"/>
+                <a:cs typeface="Arial"/>
+                <a:sym typeface="Arial"/>
+              </a:defRPr>
+            </a:lvl5pPr>
+            <a:lvl6pPr algn="ctr" indent="0" lvl="5" marL="0">
+              <a:spcBef>
+                <a:spcPts val="0"/>
+              </a:spcBef>
+              <a:buNone/>
+              <a:defRPr sz="700">
+                <a:solidFill>
+                  <a:schemeClr val="dk1"/>
+                </a:solidFill>
+                <a:latin typeface="Arial"/>
+                <a:ea typeface="Arial"/>
+                <a:cs typeface="Arial"/>
+                <a:sym typeface="Arial"/>
+              </a:defRPr>
+            </a:lvl6pPr>
+            <a:lvl7pPr algn="ctr" indent="0" lvl="6" marL="0">
+              <a:spcBef>
+                <a:spcPts val="0"/>
+              </a:spcBef>
+              <a:buNone/>
+              <a:defRPr sz="700">
+                <a:solidFill>
+                  <a:schemeClr val="dk1"/>
+                </a:solidFill>
+                <a:latin typeface="Arial"/>
+                <a:ea typeface="Arial"/>
+                <a:cs typeface="Arial"/>
+                <a:sym typeface="Arial"/>
+              </a:defRPr>
+            </a:lvl7pPr>
+            <a:lvl8pPr algn="ctr" indent="0" lvl="7" marL="0">
+              <a:spcBef>
+                <a:spcPts val="0"/>
+              </a:spcBef>
+              <a:buNone/>
+              <a:defRPr sz="700">
+                <a:solidFill>
+                  <a:schemeClr val="dk1"/>
+                </a:solidFill>
+                <a:latin typeface="Arial"/>
+                <a:ea typeface="Arial"/>
+                <a:cs typeface="Arial"/>
+                <a:sym typeface="Arial"/>
+              </a:defRPr>
+            </a:lvl8pPr>
+            <a:lvl9pPr algn="ctr" indent="0" lvl="8" marL="0">
+              <a:spcBef>
+                <a:spcPts val="0"/>
+              </a:spcBef>
+              <a:buNone/>
+              <a:defRPr sz="700">
+                <a:solidFill>
+                  <a:schemeClr val="dk1"/>
+                </a:solidFill>
+                <a:latin typeface="Arial"/>
+                <a:ea typeface="Arial"/>
+                <a:cs typeface="Arial"/>
+                <a:sym typeface="Arial"/>
+              </a:defRPr>
+            </a:lvl9pPr>
+          </a:lstStyle>
+          <a:p>
+            <a:pPr algn="ctr" indent="0" lvl="0" marL="0" rtl="0">
+              <a:spcBef>
+                <a:spcPts val="0"/>
+              </a:spcBef>
+              <a:spcAft>
+                <a:spcPts val="0"/>
+              </a:spcAft>
+              <a:buNone/>
+            </a:pPr>
+            <a:fld id="{00000000-1234-1234-1234-123412341234}" type="slidenum">
+              <a:rPr lang="en-US"/>
+              <a:t>‹#›</a:t>
+            </a:fld>
+            <a:endParaRPr/>
+          </a:p>
+        </p:txBody>
+      </p:sp>
+    </p:spTree>
+  </p:cSld>
+</p:sld>
+</file>
+
+<file path=ppt/slides/slide35.xml><?xml version="1.0" encoding="utf-8"?>
+<p:sld xmlns:a="http://schemas.openxmlformats.org/drawingml/2006/main" xmlns:r="http://schemas.openxmlformats.org/officeDocument/2006/relationships" xmlns:p="http://schemas.openxmlformats.org/presentationml/2006/main">
+  <p:cSld>
+    <p:spTree>
+      <p:nvGrpSpPr>
+        <p:cNvPr id="428" name="Shape 428"/>
+        <p:cNvGrpSpPr/>
+        <p:nvPr/>
+      </p:nvGrpSpPr>
+      <p:grpSpPr>
+        <a:xfrm>
+          <a:off x="0" y="0"/>
+          <a:ext cx="0" cy="0"/>
+          <a:chOff x="0" y="0"/>
+          <a:chExt cx="0" cy="0"/>
+        </a:xfrm>
+      </p:grpSpPr>
+      <p:sp>
+        <p:nvSpPr>
+          <p:cNvPr id="436" name="Google Shape;436;p31"/>
+          <p:cNvSpPr txBox="1"/>
+          <p:nvPr>
+            <p:ph type="title"/>
+          </p:nvPr>
+        </p:nvSpPr>
+        <p:spPr>
+          <a:xfrm>
+            <a:off x="771525" y="200025"/>
+            <a:ext cx="10582275" cy="790575"/>
+          </a:xfrm>
+          <a:prstGeom prst="rect">
+            <a:avLst/>
+          </a:prstGeom>
+          <a:noFill/>
+          <a:ln>
+            <a:noFill/>
+          </a:ln>
+        </p:spPr>
+        <p:txBody>
+          <a:bodyPr/>
+          <a:lstStyle/>
+          <a:p>
+            <a:pPr lvl="0" indent="0" marL="0">
+              <a:buNone/>
+            </a:pPr>
+            <a:r>
+              <a:rPr/>
+              <a:t>v6 chính xác hơn — vì sao vẫn không đổi</a:t>
+            </a:r>
+          </a:p>
+        </p:txBody>
+      </p:sp>
+      <p:sp>
+        <p:nvSpPr>
+          <p:cNvPr id="437" name="Google Shape;437;p31"/>
+          <p:cNvSpPr txBox="1"/>
+          <p:nvPr>
+            <p:ph idx="2" sz="half" type="body"/>
+          </p:nvPr>
+        </p:nvSpPr>
+        <p:spPr/>
+        <p:txBody>
+          <a:bodyPr/>
+          <a:lstStyle/>
+          <a:p>
+            <a:pPr lvl="0" indent="0" marL="0">
+              <a:buNone/>
+            </a:pPr>
+            <a:r>
+              <a:rPr/>
+              <a:t>Gói không có bản </a:t>
+            </a:r>
+            <a:r>
+              <a:rPr b="1"/>
+              <a:t>Tiny</a:t>
+            </a:r>
+            <a:r>
+              <a:rPr/>
+              <a:t> — chỉ Medium, chậm </a:t>
+            </a:r>
+            <a:r>
+              <a:rPr b="1"/>
+              <a:t>16,8 lần</a:t>
+            </a:r>
+            <a:r>
+              <a:rPr/>
+              <a:t>. Ràng buộc </a:t>
+            </a:r>
+            <a:r>
+              <a:rPr b="1"/>
+              <a:t>phần cứng</a:t>
+            </a:r>
+          </a:p>
+        </p:txBody>
+      </p:sp>
+      <p:graphicFrame>
+        <p:nvGraphicFramePr>
+          <p:cNvPr id="6" name="Content Placeholder 5"/>
+          <p:cNvGraphicFramePr>
+            <a:graphicFrameLocks noGrp="1"/>
+          </p:cNvGraphicFramePr>
+          <p:nvPr>
+            <p:ph idx="1"/>
+          </p:nvPr>
+        </p:nvGraphicFramePr>
+        <p:xfrm>
+          <a:off x="762000" y="2209800"/>
+          <a:ext cx="10579100" cy="3962400"/>
+        </p:xfrm>
+        <a:graphic>
+          <a:graphicData uri="http://schemas.openxmlformats.org/drawingml/2006/table">
+            <a:tbl>
+              <a:tblPr firstRow="1" bandRow="1">
+                <a:tableStyleId>{45BEF19B-5B1D-4A26-B267-ECC71EF7E2D4}</a:tableStyleId>
+              </a:tblPr>
+              <a:tblGrid>
+                <a:gridCol w="3517900"/>
+                <a:gridCol w="3517900"/>
+                <a:gridCol w="3517900"/>
+              </a:tblGrid>
+              <a:tr h="0">
+                <a:tc>
+                  <a:txBody>
+                    <a:bodyPr/>
+                    <a:lstStyle/>
+                    <a:p>
+                      <a:pPr lvl="0" indent="0" marL="0">
+                        <a:buNone/>
+                      </a:pPr>
+                      <a:r>
+                        <a:rPr/>
+                        <a:t>Chỉ tiêu</a:t>
+                      </a:r>
+                    </a:p>
+                  </a:txBody>
+                  <a:tcPr/>
+                </a:tc>
+                <a:tc>
+                  <a:txBody>
+                    <a:bodyPr/>
+                    <a:lstStyle/>
+                    <a:p>
+                      <a:pPr lvl="0" indent="0" marL="0" algn="r">
+                        <a:buNone/>
+                      </a:pPr>
+                      <a:r>
+                        <a:rPr/>
+                        <a:t>Hiện tại</a:t>
+                      </a:r>
+                    </a:p>
+                  </a:txBody>
+                  <a:tcPr/>
+                </a:tc>
+                <a:tc>
+                  <a:txBody>
+                    <a:bodyPr/>
+                    <a:lstStyle/>
+                    <a:p>
+                      <a:pPr lvl="0" indent="0" marL="0">
+                        <a:buNone/>
+                      </a:pPr>
+                      <a:r>
+                        <a:rPr/>
+                        <a:t>Nếu đổi sang v6</a:t>
+                      </a:r>
+                    </a:p>
+                  </a:txBody>
+                  <a:tcPr/>
+                </a:tc>
+              </a:tr>
+              <a:tr h="0">
+                <a:tc>
+                  <a:txBody>
+                    <a:bodyPr/>
+                    <a:lstStyle/>
+                    <a:p>
+                      <a:pPr lvl="0" indent="0" marL="0">
+                        <a:buNone/>
+                      </a:pPr>
+                      <a:r>
+                        <a:rPr/>
+                        <a:t>NFR-P1 p95</a:t>
+                      </a:r>
+                    </a:p>
+                  </a:txBody>
+                </a:tc>
+                <a:tc>
+                  <a:txBody>
+                    <a:bodyPr/>
+                    <a:lstStyle/>
+                    <a:p>
+                      <a:pPr lvl="0" indent="0" marL="0" algn="r">
+                        <a:buNone/>
+                      </a:pPr>
+                      <a:r>
+                        <a:rPr/>
+                        <a:t>1.143 ms 🟡</a:t>
+                      </a:r>
+                    </a:p>
+                  </a:txBody>
+                </a:tc>
+                <a:tc>
+                  <a:txBody>
+                    <a:bodyPr/>
+                    <a:lstStyle/>
+                    <a:p>
+                      <a:pPr lvl="0" indent="0" marL="0">
+                        <a:buNone/>
+                      </a:pPr>
+                      <a:r>
+                        <a:rPr b="1"/>
+                        <a:t>vượt sàn</a:t>
+                      </a:r>
+                      <a:r>
+                        <a:rPr/>
+                        <a:t> ❌</a:t>
+                      </a:r>
+                    </a:p>
+                  </a:txBody>
+                </a:tc>
+              </a:tr>
+              <a:tr h="0">
+                <a:tc>
+                  <a:txBody>
+                    <a:bodyPr/>
+                    <a:lstStyle/>
+                    <a:p>
+                      <a:pPr lvl="0" indent="0" marL="0">
+                        <a:buNone/>
+                      </a:pPr>
+                      <a:r>
+                        <a:rPr/>
+                        <a:t>NFR-P2 FPS</a:t>
+                      </a:r>
+                    </a:p>
+                  </a:txBody>
+                </a:tc>
+                <a:tc>
+                  <a:txBody>
+                    <a:bodyPr/>
+                    <a:lstStyle/>
+                    <a:p>
+                      <a:pPr lvl="0" indent="0" marL="0" algn="r">
+                        <a:buNone/>
+                      </a:pPr>
+                      <a:r>
+                        <a:rPr/>
+                        <a:t>2,379 ❌</a:t>
+                      </a:r>
+                    </a:p>
+                  </a:txBody>
+                </a:tc>
+                <a:tc>
+                  <a:txBody>
+                    <a:bodyPr/>
+                    <a:lstStyle/>
+                    <a:p>
+                      <a:pPr lvl="0" indent="0" marL="0">
+                        <a:buNone/>
+                      </a:pPr>
+                      <a:r>
+                        <a:rPr/>
+                        <a:t>tệ hơn</a:t>
+                      </a:r>
+                    </a:p>
+                  </a:txBody>
+                </a:tc>
+              </a:tr>
+            </a:tbl>
+          </a:graphicData>
+        </a:graphic>
+      </p:graphicFrame>
+      <p:sp>
+        <p:nvSpPr>
+          <p:cNvPr id="449" name="Google Shape;449;p31"/>
+          <p:cNvSpPr txBox="1"/>
+          <p:nvPr>
+            <p:ph idx="12" type="sldNum"/>
+          </p:nvPr>
+        </p:nvSpPr>
+        <p:spPr>
+          <a:xfrm>
+            <a:off x="58380" y="6508358"/>
+            <a:ext cx="349642" cy="349642"/>
+          </a:xfrm>
+          <a:prstGeom prst="rect">
+            <a:avLst/>
+          </a:prstGeom>
+          <a:noFill/>
+          <a:ln>
+            <a:noFill/>
+          </a:ln>
+        </p:spPr>
+        <p:txBody>
+          <a:bodyPr anchor="ctr" anchorCtr="0" bIns="45700" lIns="91425" rIns="91425" spcFirstLastPara="1" tIns="45700" wrap="square">
+            <a:noAutofit/>
+          </a:bodyPr>
+          <a:lstStyle>
+            <a:lvl1pPr algn="ctr" indent="0" lvl="0" marL="0">
+              <a:spcBef>
+                <a:spcPts val="0"/>
+              </a:spcBef>
+              <a:buNone/>
+              <a:defRPr sz="700">
+                <a:solidFill>
+                  <a:schemeClr val="dk1"/>
+                </a:solidFill>
+                <a:latin typeface="Arial"/>
+                <a:ea typeface="Arial"/>
+                <a:cs typeface="Arial"/>
+                <a:sym typeface="Arial"/>
+              </a:defRPr>
+            </a:lvl1pPr>
+            <a:lvl2pPr algn="ctr" indent="0" lvl="1" marL="0">
+              <a:spcBef>
+                <a:spcPts val="0"/>
+              </a:spcBef>
+              <a:buNone/>
+              <a:defRPr sz="700">
+                <a:solidFill>
+                  <a:schemeClr val="dk1"/>
+                </a:solidFill>
+                <a:latin typeface="Arial"/>
+                <a:ea typeface="Arial"/>
+                <a:cs typeface="Arial"/>
+                <a:sym typeface="Arial"/>
+              </a:defRPr>
+            </a:lvl2pPr>
+            <a:lvl3pPr algn="ctr" indent="0" lvl="2" marL="0">
+              <a:spcBef>
+                <a:spcPts val="0"/>
+              </a:spcBef>
+              <a:buNone/>
+              <a:defRPr sz="700">
+                <a:solidFill>
+                  <a:schemeClr val="dk1"/>
+                </a:solidFill>
+                <a:latin typeface="Arial"/>
+                <a:ea typeface="Arial"/>
+                <a:cs typeface="Arial"/>
+                <a:sym typeface="Arial"/>
+              </a:defRPr>
+            </a:lvl3pPr>
+            <a:lvl4pPr algn="ctr" indent="0" lvl="3" marL="0">
+              <a:spcBef>
+                <a:spcPts val="0"/>
+              </a:spcBef>
+              <a:buNone/>
+              <a:defRPr sz="700">
+                <a:solidFill>
+                  <a:schemeClr val="dk1"/>
+                </a:solidFill>
+                <a:latin typeface="Arial"/>
+                <a:ea typeface="Arial"/>
+                <a:cs typeface="Arial"/>
+                <a:sym typeface="Arial"/>
+              </a:defRPr>
+            </a:lvl4pPr>
+            <a:lvl5pPr algn="ctr" indent="0" lvl="4" marL="0">
+              <a:spcBef>
+                <a:spcPts val="0"/>
+              </a:spcBef>
+              <a:buNone/>
+              <a:defRPr sz="700">
+                <a:solidFill>
+                  <a:schemeClr val="dk1"/>
+                </a:solidFill>
+                <a:latin typeface="Arial"/>
+                <a:ea typeface="Arial"/>
+                <a:cs typeface="Arial"/>
+                <a:sym typeface="Arial"/>
+              </a:defRPr>
+            </a:lvl5pPr>
+            <a:lvl6pPr algn="ctr" indent="0" lvl="5" marL="0">
+              <a:spcBef>
+                <a:spcPts val="0"/>
+              </a:spcBef>
+              <a:buNone/>
+              <a:defRPr sz="700">
+                <a:solidFill>
+                  <a:schemeClr val="dk1"/>
+                </a:solidFill>
+                <a:latin typeface="Arial"/>
+                <a:ea typeface="Arial"/>
+                <a:cs typeface="Arial"/>
+                <a:sym typeface="Arial"/>
+              </a:defRPr>
+            </a:lvl6pPr>
+            <a:lvl7pPr algn="ctr" indent="0" lvl="6" marL="0">
+              <a:spcBef>
+                <a:spcPts val="0"/>
+              </a:spcBef>
+              <a:buNone/>
+              <a:defRPr sz="700">
+                <a:solidFill>
+                  <a:schemeClr val="dk1"/>
+                </a:solidFill>
+                <a:latin typeface="Arial"/>
+                <a:ea typeface="Arial"/>
+                <a:cs typeface="Arial"/>
+                <a:sym typeface="Arial"/>
+              </a:defRPr>
+            </a:lvl7pPr>
+            <a:lvl8pPr algn="ctr" indent="0" lvl="7" marL="0">
+              <a:spcBef>
+                <a:spcPts val="0"/>
+              </a:spcBef>
+              <a:buNone/>
+              <a:defRPr sz="700">
+                <a:solidFill>
+                  <a:schemeClr val="dk1"/>
+                </a:solidFill>
+                <a:latin typeface="Arial"/>
+                <a:ea typeface="Arial"/>
+                <a:cs typeface="Arial"/>
+                <a:sym typeface="Arial"/>
+              </a:defRPr>
+            </a:lvl8pPr>
+            <a:lvl9pPr algn="ctr" indent="0" lvl="8" marL="0">
+              <a:spcBef>
+                <a:spcPts val="0"/>
+              </a:spcBef>
+              <a:buNone/>
+              <a:defRPr sz="700">
+                <a:solidFill>
+                  <a:schemeClr val="dk1"/>
+                </a:solidFill>
+                <a:latin typeface="Arial"/>
+                <a:ea typeface="Arial"/>
+                <a:cs typeface="Arial"/>
+                <a:sym typeface="Arial"/>
+              </a:defRPr>
+            </a:lvl9pPr>
+          </a:lstStyle>
+          <a:p>
+            <a:pPr algn="ctr" indent="0" lvl="0" marL="0" rtl="0">
+              <a:spcBef>
+                <a:spcPts val="0"/>
+              </a:spcBef>
+              <a:spcAft>
+                <a:spcPts val="0"/>
+              </a:spcAft>
+              <a:buNone/>
+            </a:pPr>
+            <a:fld id="{00000000-1234-1234-1234-123412341234}" type="slidenum">
+              <a:rPr lang="en-US"/>
+              <a:t>‹#›</a:t>
+            </a:fld>
+            <a:endParaRPr/>
+          </a:p>
+        </p:txBody>
+      </p:sp>
+    </p:spTree>
+  </p:cSld>
+</p:sld>
+</file>
+
 <file path=ppt/slides/slide4.xml><?xml version="1.0" encoding="utf-8"?>
 <p:sld xmlns:a="http://schemas.openxmlformats.org/drawingml/2006/main" xmlns:r="http://schemas.openxmlformats.org/officeDocument/2006/relationships" xmlns:p="http://schemas.openxmlformats.org/presentationml/2006/main">
   <p:cSld>

</xml_diff>